<commit_message>
docs: update presentation slides with latest research findings
</commit_message>
<xml_diff>
--- a/docs/paper-thesis/ppt/presentation.pptx
+++ b/docs/paper-thesis/ppt/presentation.pptx
@@ -5,20 +5,20 @@
     <p:sldMasterId id="2147483648" r:id="rId1"/>
   </p:sldMasterIdLst>
   <p:sldIdLst>
-    <p:sldId id="256" r:id="rId7"/>
-    <p:sldId id="257" r:id="rId8"/>
-    <p:sldId id="258" r:id="rId9"/>
-    <p:sldId id="259" r:id="rId10"/>
-    <p:sldId id="260" r:id="rId11"/>
-    <p:sldId id="261" r:id="rId12"/>
-    <p:sldId id="262" r:id="rId13"/>
-    <p:sldId id="263" r:id="rId14"/>
-    <p:sldId id="264" r:id="rId15"/>
-    <p:sldId id="265" r:id="rId16"/>
-    <p:sldId id="266" r:id="rId17"/>
-    <p:sldId id="267" r:id="rId18"/>
+    <p:sldId id="256" r:id="rId2"/>
+    <p:sldId id="257" r:id="rId3"/>
+    <p:sldId id="258" r:id="rId4"/>
+    <p:sldId id="259" r:id="rId5"/>
+    <p:sldId id="260" r:id="rId6"/>
+    <p:sldId id="261" r:id="rId7"/>
+    <p:sldId id="262" r:id="rId8"/>
+    <p:sldId id="263" r:id="rId9"/>
+    <p:sldId id="264" r:id="rId10"/>
+    <p:sldId id="265" r:id="rId11"/>
+    <p:sldId id="266" r:id="rId12"/>
+    <p:sldId id="267" r:id="rId13"/>
   </p:sldIdLst>
-  <p:sldSz cx="12191695" cy="6858000" type="screen4x3"/>
+  <p:sldSz cx="12192000" cy="6858000"/>
   <p:notesSz cx="6858000" cy="9144000"/>
   <p:defaultTextStyle>
     <a:defPPr>
@@ -115,7 +115,31 @@
       </a:defRPr>
     </a:lvl9pPr>
   </p:defaultTextStyle>
+  <p:extLst>
+    <p:ext uri="{EFAFB233-063F-42B5-8137-9DF3F51BA10A}">
+      <p15:sldGuideLst xmlns:p15="http://schemas.microsoft.com/office/powerpoint/2012/main">
+        <p15:guide id="1" orient="horz" pos="2160">
+          <p15:clr>
+            <a:srgbClr val="A4A3A4"/>
+          </p15:clr>
+        </p15:guide>
+        <p15:guide id="2" pos="2880">
+          <p15:clr>
+            <a:srgbClr val="A4A3A4"/>
+          </p15:clr>
+        </p15:guide>
+      </p15:sldGuideLst>
+    </p:ext>
+  </p:extLst>
 </p:presentation>
+</file>
+
+<file path=ppt/revisionInfo.xml><?xml version="1.0" encoding="utf-8"?>
+<p1510:revInfo xmlns:a="http://schemas.openxmlformats.org/drawingml/2006/main" xmlns:r="http://schemas.openxmlformats.org/officeDocument/2006/relationships" xmlns:p1510="http://schemas.microsoft.com/office/powerpoint/2015/10/main">
+  <p1510:revLst>
+    <p1510:client id="{7CF2E6CB-3F77-4195-BA20-6F1D26E3B379}" v="10" dt="2026-06-26T16:31:57.951"/>
+  </p1510:revLst>
+</p1510:revInfo>
 </file>
 
 <file path=ppt/slideLayouts/slideLayout1.xml><?xml version="1.0" encoding="utf-8"?>
@@ -156,10 +180,9 @@
           <a:lstStyle/>
           <a:p>
             <a:r>
-              <a:rPr lang="en-US" smtClean="0"/>
+              <a:rPr lang="en-US"/>
               <a:t>Click to edit Master title style</a:t>
             </a:r>
-            <a:endParaRPr lang="en-US"/>
           </a:p>
         </p:txBody>
       </p:sp>
@@ -275,10 +298,9 @@
           </a:lstStyle>
           <a:p>
             <a:r>
-              <a:rPr lang="en-US" smtClean="0"/>
+              <a:rPr lang="en-US"/>
               <a:t>Click to edit Master subtitle style</a:t>
             </a:r>
-            <a:endParaRPr lang="en-US"/>
           </a:p>
         </p:txBody>
       </p:sp>
@@ -299,7 +321,7 @@
           <a:p>
             <a:fld id="{5BCAD085-E8A6-8845-BD4E-CB4CCA059FC4}" type="datetimeFigureOut">
               <a:rPr lang="en-US" smtClean="0"/>
-              <a:t>1/27/13</a:t>
+              <a:t>6/26/2026</a:t>
             </a:fld>
             <a:endParaRPr lang="en-US"/>
           </a:p>
@@ -393,10 +415,9 @@
           <a:lstStyle/>
           <a:p>
             <a:r>
-              <a:rPr lang="en-US" smtClean="0"/>
+              <a:rPr lang="en-US"/>
               <a:t>Click to edit Master title style</a:t>
             </a:r>
-            <a:endParaRPr lang="en-US"/>
           </a:p>
         </p:txBody>
       </p:sp>
@@ -417,38 +438,37 @@
           <a:p>
             <a:pPr lvl="0"/>
             <a:r>
-              <a:rPr lang="en-US" smtClean="0"/>
+              <a:rPr lang="en-US"/>
               <a:t>Click to edit Master text styles</a:t>
             </a:r>
           </a:p>
           <a:p>
             <a:pPr lvl="1"/>
             <a:r>
-              <a:rPr lang="en-US" smtClean="0"/>
+              <a:rPr lang="en-US"/>
               <a:t>Second level</a:t>
             </a:r>
           </a:p>
           <a:p>
             <a:pPr lvl="2"/>
             <a:r>
-              <a:rPr lang="en-US" smtClean="0"/>
+              <a:rPr lang="en-US"/>
               <a:t>Third level</a:t>
             </a:r>
           </a:p>
           <a:p>
             <a:pPr lvl="3"/>
             <a:r>
-              <a:rPr lang="en-US" smtClean="0"/>
+              <a:rPr lang="en-US"/>
               <a:t>Fourth level</a:t>
             </a:r>
           </a:p>
           <a:p>
             <a:pPr lvl="4"/>
             <a:r>
-              <a:rPr lang="en-US" smtClean="0"/>
+              <a:rPr lang="en-US"/>
               <a:t>Fifth level</a:t>
             </a:r>
-            <a:endParaRPr lang="en-US"/>
           </a:p>
         </p:txBody>
       </p:sp>
@@ -469,7 +489,7 @@
           <a:p>
             <a:fld id="{5BCAD085-E8A6-8845-BD4E-CB4CCA059FC4}" type="datetimeFigureOut">
               <a:rPr lang="en-US" smtClean="0"/>
-              <a:t>1/27/13</a:t>
+              <a:t>6/26/2026</a:t>
             </a:fld>
             <a:endParaRPr lang="en-US"/>
           </a:p>
@@ -568,10 +588,9 @@
           <a:lstStyle/>
           <a:p>
             <a:r>
-              <a:rPr lang="en-US" smtClean="0"/>
+              <a:rPr lang="en-US"/>
               <a:t>Click to edit Master title style</a:t>
             </a:r>
-            <a:endParaRPr lang="en-US"/>
           </a:p>
         </p:txBody>
       </p:sp>
@@ -597,38 +616,37 @@
           <a:p>
             <a:pPr lvl="0"/>
             <a:r>
-              <a:rPr lang="en-US" smtClean="0"/>
+              <a:rPr lang="en-US"/>
               <a:t>Click to edit Master text styles</a:t>
             </a:r>
           </a:p>
           <a:p>
             <a:pPr lvl="1"/>
             <a:r>
-              <a:rPr lang="en-US" smtClean="0"/>
+              <a:rPr lang="en-US"/>
               <a:t>Second level</a:t>
             </a:r>
           </a:p>
           <a:p>
             <a:pPr lvl="2"/>
             <a:r>
-              <a:rPr lang="en-US" smtClean="0"/>
+              <a:rPr lang="en-US"/>
               <a:t>Third level</a:t>
             </a:r>
           </a:p>
           <a:p>
             <a:pPr lvl="3"/>
             <a:r>
-              <a:rPr lang="en-US" smtClean="0"/>
+              <a:rPr lang="en-US"/>
               <a:t>Fourth level</a:t>
             </a:r>
           </a:p>
           <a:p>
             <a:pPr lvl="4"/>
             <a:r>
-              <a:rPr lang="en-US" smtClean="0"/>
+              <a:rPr lang="en-US"/>
               <a:t>Fifth level</a:t>
             </a:r>
-            <a:endParaRPr lang="en-US"/>
           </a:p>
         </p:txBody>
       </p:sp>
@@ -649,7 +667,7 @@
           <a:p>
             <a:fld id="{5BCAD085-E8A6-8845-BD4E-CB4CCA059FC4}" type="datetimeFigureOut">
               <a:rPr lang="en-US" smtClean="0"/>
-              <a:t>1/27/13</a:t>
+              <a:t>6/26/2026</a:t>
             </a:fld>
             <a:endParaRPr lang="en-US"/>
           </a:p>
@@ -743,10 +761,9 @@
           <a:lstStyle/>
           <a:p>
             <a:r>
-              <a:rPr lang="en-US" smtClean="0"/>
+              <a:rPr lang="en-US"/>
               <a:t>Click to edit Master title style</a:t>
             </a:r>
-            <a:endParaRPr lang="en-US"/>
           </a:p>
         </p:txBody>
       </p:sp>
@@ -767,38 +784,37 @@
           <a:p>
             <a:pPr lvl="0"/>
             <a:r>
-              <a:rPr lang="en-US" smtClean="0"/>
+              <a:rPr lang="en-US"/>
               <a:t>Click to edit Master text styles</a:t>
             </a:r>
           </a:p>
           <a:p>
             <a:pPr lvl="1"/>
             <a:r>
-              <a:rPr lang="en-US" smtClean="0"/>
+              <a:rPr lang="en-US"/>
               <a:t>Second level</a:t>
             </a:r>
           </a:p>
           <a:p>
             <a:pPr lvl="2"/>
             <a:r>
-              <a:rPr lang="en-US" smtClean="0"/>
+              <a:rPr lang="en-US"/>
               <a:t>Third level</a:t>
             </a:r>
           </a:p>
           <a:p>
             <a:pPr lvl="3"/>
             <a:r>
-              <a:rPr lang="en-US" smtClean="0"/>
+              <a:rPr lang="en-US"/>
               <a:t>Fourth level</a:t>
             </a:r>
           </a:p>
           <a:p>
             <a:pPr lvl="4"/>
             <a:r>
-              <a:rPr lang="en-US" smtClean="0"/>
+              <a:rPr lang="en-US"/>
               <a:t>Fifth level</a:t>
             </a:r>
-            <a:endParaRPr lang="en-US"/>
           </a:p>
         </p:txBody>
       </p:sp>
@@ -819,7 +835,7 @@
           <a:p>
             <a:fld id="{5BCAD085-E8A6-8845-BD4E-CB4CCA059FC4}" type="datetimeFigureOut">
               <a:rPr lang="en-US" smtClean="0"/>
-              <a:t>1/27/13</a:t>
+              <a:t>6/26/2026</a:t>
             </a:fld>
             <a:endParaRPr lang="en-US"/>
           </a:p>
@@ -922,10 +938,9 @@
           </a:lstStyle>
           <a:p>
             <a:r>
-              <a:rPr lang="en-US" smtClean="0"/>
+              <a:rPr lang="en-US"/>
               <a:t>Click to edit Master title style</a:t>
             </a:r>
-            <a:endParaRPr lang="en-US"/>
           </a:p>
         </p:txBody>
       </p:sp>
@@ -1042,7 +1057,7 @@
           <a:p>
             <a:pPr lvl="0"/>
             <a:r>
-              <a:rPr lang="en-US" smtClean="0"/>
+              <a:rPr lang="en-US"/>
               <a:t>Click to edit Master text styles</a:t>
             </a:r>
           </a:p>
@@ -1065,7 +1080,7 @@
           <a:p>
             <a:fld id="{5BCAD085-E8A6-8845-BD4E-CB4CCA059FC4}" type="datetimeFigureOut">
               <a:rPr lang="en-US" smtClean="0"/>
-              <a:t>1/27/13</a:t>
+              <a:t>6/26/2026</a:t>
             </a:fld>
             <a:endParaRPr lang="en-US"/>
           </a:p>
@@ -1159,10 +1174,9 @@
           <a:lstStyle/>
           <a:p>
             <a:r>
-              <a:rPr lang="en-US" smtClean="0"/>
+              <a:rPr lang="en-US"/>
               <a:t>Click to edit Master title style</a:t>
             </a:r>
-            <a:endParaRPr lang="en-US"/>
           </a:p>
         </p:txBody>
       </p:sp>
@@ -1216,38 +1230,37 @@
           <a:p>
             <a:pPr lvl="0"/>
             <a:r>
-              <a:rPr lang="en-US" smtClean="0"/>
+              <a:rPr lang="en-US"/>
               <a:t>Click to edit Master text styles</a:t>
             </a:r>
           </a:p>
           <a:p>
             <a:pPr lvl="1"/>
             <a:r>
-              <a:rPr lang="en-US" smtClean="0"/>
+              <a:rPr lang="en-US"/>
               <a:t>Second level</a:t>
             </a:r>
           </a:p>
           <a:p>
             <a:pPr lvl="2"/>
             <a:r>
-              <a:rPr lang="en-US" smtClean="0"/>
+              <a:rPr lang="en-US"/>
               <a:t>Third level</a:t>
             </a:r>
           </a:p>
           <a:p>
             <a:pPr lvl="3"/>
             <a:r>
-              <a:rPr lang="en-US" smtClean="0"/>
+              <a:rPr lang="en-US"/>
               <a:t>Fourth level</a:t>
             </a:r>
           </a:p>
           <a:p>
             <a:pPr lvl="4"/>
             <a:r>
-              <a:rPr lang="en-US" smtClean="0"/>
+              <a:rPr lang="en-US"/>
               <a:t>Fifth level</a:t>
             </a:r>
-            <a:endParaRPr lang="en-US"/>
           </a:p>
         </p:txBody>
       </p:sp>
@@ -1301,38 +1314,37 @@
           <a:p>
             <a:pPr lvl="0"/>
             <a:r>
-              <a:rPr lang="en-US" smtClean="0"/>
+              <a:rPr lang="en-US"/>
               <a:t>Click to edit Master text styles</a:t>
             </a:r>
           </a:p>
           <a:p>
             <a:pPr lvl="1"/>
             <a:r>
-              <a:rPr lang="en-US" smtClean="0"/>
+              <a:rPr lang="en-US"/>
               <a:t>Second level</a:t>
             </a:r>
           </a:p>
           <a:p>
             <a:pPr lvl="2"/>
             <a:r>
-              <a:rPr lang="en-US" smtClean="0"/>
+              <a:rPr lang="en-US"/>
               <a:t>Third level</a:t>
             </a:r>
           </a:p>
           <a:p>
             <a:pPr lvl="3"/>
             <a:r>
-              <a:rPr lang="en-US" smtClean="0"/>
+              <a:rPr lang="en-US"/>
               <a:t>Fourth level</a:t>
             </a:r>
           </a:p>
           <a:p>
             <a:pPr lvl="4"/>
             <a:r>
-              <a:rPr lang="en-US" smtClean="0"/>
+              <a:rPr lang="en-US"/>
               <a:t>Fifth level</a:t>
             </a:r>
-            <a:endParaRPr lang="en-US"/>
           </a:p>
         </p:txBody>
       </p:sp>
@@ -1353,7 +1365,7 @@
           <a:p>
             <a:fld id="{5BCAD085-E8A6-8845-BD4E-CB4CCA059FC4}" type="datetimeFigureOut">
               <a:rPr lang="en-US" smtClean="0"/>
-              <a:t>1/27/13</a:t>
+              <a:t>6/26/2026</a:t>
             </a:fld>
             <a:endParaRPr lang="en-US"/>
           </a:p>
@@ -1451,10 +1463,9 @@
           </a:lstStyle>
           <a:p>
             <a:r>
-              <a:rPr lang="en-US" smtClean="0"/>
+              <a:rPr lang="en-US"/>
               <a:t>Click to edit Master title style</a:t>
             </a:r>
-            <a:endParaRPr lang="en-US"/>
           </a:p>
         </p:txBody>
       </p:sp>
@@ -1517,7 +1528,7 @@
           <a:p>
             <a:pPr lvl="0"/>
             <a:r>
-              <a:rPr lang="en-US" smtClean="0"/>
+              <a:rPr lang="en-US"/>
               <a:t>Click to edit Master text styles</a:t>
             </a:r>
           </a:p>
@@ -1573,38 +1584,37 @@
           <a:p>
             <a:pPr lvl="0"/>
             <a:r>
-              <a:rPr lang="en-US" smtClean="0"/>
+              <a:rPr lang="en-US"/>
               <a:t>Click to edit Master text styles</a:t>
             </a:r>
           </a:p>
           <a:p>
             <a:pPr lvl="1"/>
             <a:r>
-              <a:rPr lang="en-US" smtClean="0"/>
+              <a:rPr lang="en-US"/>
               <a:t>Second level</a:t>
             </a:r>
           </a:p>
           <a:p>
             <a:pPr lvl="2"/>
             <a:r>
-              <a:rPr lang="en-US" smtClean="0"/>
+              <a:rPr lang="en-US"/>
               <a:t>Third level</a:t>
             </a:r>
           </a:p>
           <a:p>
             <a:pPr lvl="3"/>
             <a:r>
-              <a:rPr lang="en-US" smtClean="0"/>
+              <a:rPr lang="en-US"/>
               <a:t>Fourth level</a:t>
             </a:r>
           </a:p>
           <a:p>
             <a:pPr lvl="4"/>
             <a:r>
-              <a:rPr lang="en-US" smtClean="0"/>
+              <a:rPr lang="en-US"/>
               <a:t>Fifth level</a:t>
             </a:r>
-            <a:endParaRPr lang="en-US"/>
           </a:p>
         </p:txBody>
       </p:sp>
@@ -1667,7 +1677,7 @@
           <a:p>
             <a:pPr lvl="0"/>
             <a:r>
-              <a:rPr lang="en-US" smtClean="0"/>
+              <a:rPr lang="en-US"/>
               <a:t>Click to edit Master text styles</a:t>
             </a:r>
           </a:p>
@@ -1723,38 +1733,37 @@
           <a:p>
             <a:pPr lvl="0"/>
             <a:r>
-              <a:rPr lang="en-US" smtClean="0"/>
+              <a:rPr lang="en-US"/>
               <a:t>Click to edit Master text styles</a:t>
             </a:r>
           </a:p>
           <a:p>
             <a:pPr lvl="1"/>
             <a:r>
-              <a:rPr lang="en-US" smtClean="0"/>
+              <a:rPr lang="en-US"/>
               <a:t>Second level</a:t>
             </a:r>
           </a:p>
           <a:p>
             <a:pPr lvl="2"/>
             <a:r>
-              <a:rPr lang="en-US" smtClean="0"/>
+              <a:rPr lang="en-US"/>
               <a:t>Third level</a:t>
             </a:r>
           </a:p>
           <a:p>
             <a:pPr lvl="3"/>
             <a:r>
-              <a:rPr lang="en-US" smtClean="0"/>
+              <a:rPr lang="en-US"/>
               <a:t>Fourth level</a:t>
             </a:r>
           </a:p>
           <a:p>
             <a:pPr lvl="4"/>
             <a:r>
-              <a:rPr lang="en-US" smtClean="0"/>
+              <a:rPr lang="en-US"/>
               <a:t>Fifth level</a:t>
             </a:r>
-            <a:endParaRPr lang="en-US"/>
           </a:p>
         </p:txBody>
       </p:sp>
@@ -1775,7 +1784,7 @@
           <a:p>
             <a:fld id="{5BCAD085-E8A6-8845-BD4E-CB4CCA059FC4}" type="datetimeFigureOut">
               <a:rPr lang="en-US" smtClean="0"/>
-              <a:t>1/27/13</a:t>
+              <a:t>6/26/2026</a:t>
             </a:fld>
             <a:endParaRPr lang="en-US"/>
           </a:p>
@@ -1869,10 +1878,9 @@
           <a:lstStyle/>
           <a:p>
             <a:r>
-              <a:rPr lang="en-US" smtClean="0"/>
+              <a:rPr lang="en-US"/>
               <a:t>Click to edit Master title style</a:t>
             </a:r>
-            <a:endParaRPr lang="en-US"/>
           </a:p>
         </p:txBody>
       </p:sp>
@@ -1893,7 +1901,7 @@
           <a:p>
             <a:fld id="{5BCAD085-E8A6-8845-BD4E-CB4CCA059FC4}" type="datetimeFigureOut">
               <a:rPr lang="en-US" smtClean="0"/>
-              <a:t>1/27/13</a:t>
+              <a:t>6/26/2026</a:t>
             </a:fld>
             <a:endParaRPr lang="en-US"/>
           </a:p>
@@ -1988,7 +1996,7 @@
           <a:p>
             <a:fld id="{5BCAD085-E8A6-8845-BD4E-CB4CCA059FC4}" type="datetimeFigureOut">
               <a:rPr lang="en-US" smtClean="0"/>
-              <a:t>1/27/13</a:t>
+              <a:t>6/26/2026</a:t>
             </a:fld>
             <a:endParaRPr lang="en-US"/>
           </a:p>
@@ -2091,10 +2099,9 @@
           </a:lstStyle>
           <a:p>
             <a:r>
-              <a:rPr lang="en-US" smtClean="0"/>
+              <a:rPr lang="en-US"/>
               <a:t>Click to edit Master title style</a:t>
             </a:r>
-            <a:endParaRPr lang="en-US"/>
           </a:p>
         </p:txBody>
       </p:sp>
@@ -2148,38 +2155,37 @@
           <a:p>
             <a:pPr lvl="0"/>
             <a:r>
-              <a:rPr lang="en-US" smtClean="0"/>
+              <a:rPr lang="en-US"/>
               <a:t>Click to edit Master text styles</a:t>
             </a:r>
           </a:p>
           <a:p>
             <a:pPr lvl="1"/>
             <a:r>
-              <a:rPr lang="en-US" smtClean="0"/>
+              <a:rPr lang="en-US"/>
               <a:t>Second level</a:t>
             </a:r>
           </a:p>
           <a:p>
             <a:pPr lvl="2"/>
             <a:r>
-              <a:rPr lang="en-US" smtClean="0"/>
+              <a:rPr lang="en-US"/>
               <a:t>Third level</a:t>
             </a:r>
           </a:p>
           <a:p>
             <a:pPr lvl="3"/>
             <a:r>
-              <a:rPr lang="en-US" smtClean="0"/>
+              <a:rPr lang="en-US"/>
               <a:t>Fourth level</a:t>
             </a:r>
           </a:p>
           <a:p>
             <a:pPr lvl="4"/>
             <a:r>
-              <a:rPr lang="en-US" smtClean="0"/>
+              <a:rPr lang="en-US"/>
               <a:t>Fifth level</a:t>
             </a:r>
-            <a:endParaRPr lang="en-US"/>
           </a:p>
         </p:txBody>
       </p:sp>
@@ -2242,7 +2248,7 @@
           <a:p>
             <a:pPr lvl="0"/>
             <a:r>
-              <a:rPr lang="en-US" smtClean="0"/>
+              <a:rPr lang="en-US"/>
               <a:t>Click to edit Master text styles</a:t>
             </a:r>
           </a:p>
@@ -2265,7 +2271,7 @@
           <a:p>
             <a:fld id="{5BCAD085-E8A6-8845-BD4E-CB4CCA059FC4}" type="datetimeFigureOut">
               <a:rPr lang="en-US" smtClean="0"/>
-              <a:t>1/27/13</a:t>
+              <a:t>6/26/2026</a:t>
             </a:fld>
             <a:endParaRPr lang="en-US"/>
           </a:p>
@@ -2368,10 +2374,9 @@
           </a:lstStyle>
           <a:p>
             <a:r>
-              <a:rPr lang="en-US" smtClean="0"/>
+              <a:rPr lang="en-US"/>
               <a:t>Click to edit Master title style</a:t>
             </a:r>
-            <a:endParaRPr lang="en-US"/>
           </a:p>
         </p:txBody>
       </p:sp>
@@ -2495,7 +2500,7 @@
           <a:p>
             <a:pPr lvl="0"/>
             <a:r>
-              <a:rPr lang="en-US" smtClean="0"/>
+              <a:rPr lang="en-US"/>
               <a:t>Click to edit Master text styles</a:t>
             </a:r>
           </a:p>
@@ -2518,7 +2523,7 @@
           <a:p>
             <a:fld id="{5BCAD085-E8A6-8845-BD4E-CB4CCA059FC4}" type="datetimeFigureOut">
               <a:rPr lang="en-US" smtClean="0"/>
-              <a:t>1/27/13</a:t>
+              <a:t>6/26/2026</a:t>
             </a:fld>
             <a:endParaRPr lang="en-US"/>
           </a:p>
@@ -2627,10 +2632,9 @@
           <a:lstStyle/>
           <a:p>
             <a:r>
-              <a:rPr lang="en-US" smtClean="0"/>
+              <a:rPr lang="en-US"/>
               <a:t>Click to edit Master title style</a:t>
             </a:r>
-            <a:endParaRPr lang="en-US"/>
           </a:p>
         </p:txBody>
       </p:sp>
@@ -2661,38 +2665,37 @@
           <a:p>
             <a:pPr lvl="0"/>
             <a:r>
-              <a:rPr lang="en-US" smtClean="0"/>
+              <a:rPr lang="en-US"/>
               <a:t>Click to edit Master text styles</a:t>
             </a:r>
           </a:p>
           <a:p>
             <a:pPr lvl="1"/>
             <a:r>
-              <a:rPr lang="en-US" smtClean="0"/>
+              <a:rPr lang="en-US"/>
               <a:t>Second level</a:t>
             </a:r>
           </a:p>
           <a:p>
             <a:pPr lvl="2"/>
             <a:r>
-              <a:rPr lang="en-US" smtClean="0"/>
+              <a:rPr lang="en-US"/>
               <a:t>Third level</a:t>
             </a:r>
           </a:p>
           <a:p>
             <a:pPr lvl="3"/>
             <a:r>
-              <a:rPr lang="en-US" smtClean="0"/>
+              <a:rPr lang="en-US"/>
               <a:t>Fourth level</a:t>
             </a:r>
           </a:p>
           <a:p>
             <a:pPr lvl="4"/>
             <a:r>
-              <a:rPr lang="en-US" smtClean="0"/>
+              <a:rPr lang="en-US"/>
               <a:t>Fifth level</a:t>
             </a:r>
-            <a:endParaRPr lang="en-US"/>
           </a:p>
         </p:txBody>
       </p:sp>
@@ -2731,7 +2734,7 @@
           <a:p>
             <a:fld id="{5BCAD085-E8A6-8845-BD4E-CB4CCA059FC4}" type="datetimeFigureOut">
               <a:rPr lang="en-US" smtClean="0"/>
-              <a:t>1/27/13</a:t>
+              <a:t>6/26/2026</a:t>
             </a:fld>
             <a:endParaRPr lang="en-US"/>
           </a:p>
@@ -3090,7 +3093,7 @@
 </file>
 
 <file path=ppt/slides/slide1.xml><?xml version="1.0" encoding="utf-8"?>
-<p:sld xmlns:a="http://schemas.openxmlformats.org/drawingml/2006/main" xmlns:p="http://schemas.openxmlformats.org/presentationml/2006/main" xmlns:r="http://schemas.openxmlformats.org/officeDocument/2006/relationships">
+<p:sld xmlns:a="http://schemas.openxmlformats.org/drawingml/2006/main" xmlns:r="http://schemas.openxmlformats.org/officeDocument/2006/relationships" xmlns:p="http://schemas.openxmlformats.org/presentationml/2006/main">
   <p:cSld>
     <p:bg>
       <p:bgPr>
@@ -3106,7 +3109,14 @@
         <p:cNvGrpSpPr/>
         <p:nvPr/>
       </p:nvGrpSpPr>
-      <p:grpSpPr/>
+      <p:grpSpPr>
+        <a:xfrm>
+          <a:off x="0" y="0"/>
+          <a:ext cx="0" cy="0"/>
+          <a:chOff x="0" y="0"/>
+          <a:chExt cx="0" cy="0"/>
+        </a:xfrm>
+      </p:grpSpPr>
       <p:sp>
         <p:nvSpPr>
           <p:cNvPr id="2" name="Rectangle 1"/>
@@ -3148,6 +3158,7 @@
           <a:lstStyle/>
           <a:p>
             <a:pPr algn="ctr"/>
+            <a:endParaRPr/>
           </a:p>
         </p:txBody>
       </p:sp>
@@ -3192,6 +3203,7 @@
           <a:lstStyle/>
           <a:p>
             <a:pPr algn="ctr"/>
+            <a:endParaRPr/>
           </a:p>
         </p:txBody>
       </p:sp>
@@ -3236,38 +3248,7 @@
           <a:lstStyle/>
           <a:p>
             <a:pPr algn="ctr"/>
-          </a:p>
-        </p:txBody>
-      </p:sp>
-      <p:sp>
-        <p:nvSpPr>
-          <p:cNvPr id="5" name="TextBox 4"/>
-          <p:cNvSpPr txBox="1"/>
-          <p:nvPr/>
-        </p:nvSpPr>
-        <p:spPr>
-          <a:xfrm>
-            <a:off x="4114800" y="731520"/>
-            <a:ext cx="8046720" cy="5303520"/>
-          </a:xfrm>
-          <a:prstGeom prst="rect">
-            <a:avLst/>
-          </a:prstGeom>
-          <a:noFill/>
-        </p:spPr>
-        <p:txBody>
-          <a:bodyPr wrap="none">
-            <a:spAutoFit/>
-          </a:bodyPr>
-          <a:lstStyle/>
-          <a:p>
-            <a:pPr algn="r"/>
-            <a:r>
-              <a:rPr sz="13000" b="1">
-                <a:latin typeface="Calibri"/>
-              </a:rPr>
-              <a:t>CMATRIX</a:t>
-            </a:r>
+            <a:endParaRPr/>
           </a:p>
         </p:txBody>
       </p:sp>
@@ -3418,6 +3399,7 @@
           <a:lstStyle/>
           <a:p>
             <a:pPr algn="ctr"/>
+            <a:endParaRPr/>
           </a:p>
         </p:txBody>
       </p:sp>
@@ -3464,6 +3446,7 @@
           <a:lstStyle/>
           <a:p>
             <a:pPr algn="ctr"/>
+            <a:endParaRPr/>
           </a:p>
         </p:txBody>
       </p:sp>
@@ -3545,6 +3528,7 @@
           <a:lstStyle/>
           <a:p>
             <a:pPr algn="ctr"/>
+            <a:endParaRPr/>
           </a:p>
         </p:txBody>
       </p:sp>
@@ -3626,6 +3610,7 @@
           <a:lstStyle/>
           <a:p>
             <a:pPr algn="ctr"/>
+            <a:endParaRPr/>
           </a:p>
         </p:txBody>
       </p:sp>
@@ -3778,7 +3763,7 @@
 </file>
 
 <file path=ppt/slides/slide10.xml><?xml version="1.0" encoding="utf-8"?>
-<p:sld xmlns:a="http://schemas.openxmlformats.org/drawingml/2006/main" xmlns:p="http://schemas.openxmlformats.org/presentationml/2006/main" xmlns:r="http://schemas.openxmlformats.org/officeDocument/2006/relationships">
+<p:sld xmlns:a="http://schemas.openxmlformats.org/drawingml/2006/main" xmlns:r="http://schemas.openxmlformats.org/officeDocument/2006/relationships" xmlns:p="http://schemas.openxmlformats.org/presentationml/2006/main">
   <p:cSld>
     <p:bg>
       <p:bgPr>
@@ -3794,7 +3779,14 @@
         <p:cNvGrpSpPr/>
         <p:nvPr/>
       </p:nvGrpSpPr>
-      <p:grpSpPr/>
+      <p:grpSpPr>
+        <a:xfrm>
+          <a:off x="0" y="0"/>
+          <a:ext cx="0" cy="0"/>
+          <a:chOff x="0" y="0"/>
+          <a:chExt cx="0" cy="0"/>
+        </a:xfrm>
+      </p:grpSpPr>
       <p:sp>
         <p:nvSpPr>
           <p:cNvPr id="2" name="Rectangle 1"/>
@@ -3836,6 +3828,7 @@
           <a:lstStyle/>
           <a:p>
             <a:pPr algn="ctr"/>
+            <a:endParaRPr/>
           </a:p>
         </p:txBody>
       </p:sp>
@@ -3880,6 +3873,7 @@
           <a:lstStyle/>
           <a:p>
             <a:pPr algn="ctr"/>
+            <a:endParaRPr/>
           </a:p>
         </p:txBody>
       </p:sp>
@@ -3924,6 +3918,7 @@
           <a:lstStyle/>
           <a:p>
             <a:pPr algn="ctr"/>
+            <a:endParaRPr/>
           </a:p>
         </p:txBody>
       </p:sp>
@@ -4038,6 +4033,7 @@
           <a:lstStyle/>
           <a:p>
             <a:pPr algn="ctr"/>
+            <a:endParaRPr/>
           </a:p>
         </p:txBody>
       </p:sp>
@@ -4084,6 +4080,7 @@
           <a:lstStyle/>
           <a:p>
             <a:pPr algn="ctr"/>
+            <a:endParaRPr/>
           </a:p>
         </p:txBody>
       </p:sp>
@@ -4131,8 +4128,8 @@
         </p:nvCxnSpPr>
         <p:spPr>
           <a:xfrm>
-            <a:off x="2560320" y="1463040.0"/>
-            <a:ext cx="1097280" cy="0.0"/>
+            <a:off x="2560320" y="0"/>
+            <a:ext cx="1097280" cy="0"/>
           </a:xfrm>
           <a:prstGeom prst="line">
             <a:avLst/>
@@ -4239,6 +4236,7 @@
           <a:lstStyle/>
           <a:p>
             <a:pPr algn="ctr"/>
+            <a:endParaRPr/>
           </a:p>
         </p:txBody>
       </p:sp>
@@ -4322,8 +4320,8 @@
         </p:nvCxnSpPr>
         <p:spPr>
           <a:xfrm>
-            <a:off x="6126480" y="1463040.0"/>
-            <a:ext cx="1097280" cy="0.0"/>
+            <a:off x="6126480" y="0"/>
+            <a:ext cx="1097280" cy="0"/>
           </a:xfrm>
           <a:prstGeom prst="line">
             <a:avLst/>
@@ -4430,6 +4428,7 @@
           <a:lstStyle/>
           <a:p>
             <a:pPr algn="ctr"/>
+            <a:endParaRPr/>
           </a:p>
         </p:txBody>
       </p:sp>
@@ -4513,8 +4512,8 @@
         </p:nvCxnSpPr>
         <p:spPr>
           <a:xfrm>
-            <a:off x="9692640" y="1463040.0"/>
-            <a:ext cx="1097280" cy="0.0"/>
+            <a:off x="9692640" y="0"/>
+            <a:ext cx="1097280" cy="0"/>
           </a:xfrm>
           <a:prstGeom prst="line">
             <a:avLst/>
@@ -4621,6 +4620,7 @@
           <a:lstStyle/>
           <a:p>
             <a:pPr algn="ctr"/>
+            <a:endParaRPr/>
           </a:p>
         </p:txBody>
       </p:sp>
@@ -4668,8 +4668,8 @@
         </p:nvCxnSpPr>
         <p:spPr>
           <a:xfrm>
-            <a:off x="4937760" y="1828800.0"/>
-            <a:ext cx="5943600" cy="0.0"/>
+            <a:off x="4937760" y="0"/>
+            <a:ext cx="5943600" cy="0"/>
           </a:xfrm>
           <a:prstGeom prst="line">
             <a:avLst/>
@@ -4775,6 +4775,7 @@
           <a:lstStyle/>
           <a:p>
             <a:pPr algn="ctr"/>
+            <a:endParaRPr/>
           </a:p>
         </p:txBody>
       </p:sp>
@@ -4819,6 +4820,7 @@
           <a:lstStyle/>
           <a:p>
             <a:pPr algn="ctr"/>
+            <a:endParaRPr/>
           </a:p>
         </p:txBody>
       </p:sp>
@@ -4900,6 +4902,7 @@
           <a:lstStyle/>
           <a:p>
             <a:pPr algn="ctr"/>
+            <a:endParaRPr/>
           </a:p>
         </p:txBody>
       </p:sp>
@@ -5017,6 +5020,7 @@
           <a:lstStyle/>
           <a:p>
             <a:pPr algn="ctr"/>
+            <a:endParaRPr/>
           </a:p>
         </p:txBody>
       </p:sp>
@@ -5133,6 +5137,7 @@
           <a:lstStyle/>
           <a:p>
             <a:pPr algn="ctr"/>
+            <a:endParaRPr/>
           </a:p>
         </p:txBody>
       </p:sp>
@@ -5249,6 +5254,7 @@
           <a:lstStyle/>
           <a:p>
             <a:pPr algn="ctr"/>
+            <a:endParaRPr/>
           </a:p>
         </p:txBody>
       </p:sp>
@@ -5365,6 +5371,7 @@
           <a:lstStyle/>
           <a:p>
             <a:pPr algn="ctr"/>
+            <a:endParaRPr/>
           </a:p>
         </p:txBody>
       </p:sp>
@@ -5409,6 +5416,7 @@
           <a:lstStyle/>
           <a:p>
             <a:pPr algn="ctr"/>
+            <a:endParaRPr/>
           </a:p>
         </p:txBody>
       </p:sp>
@@ -5490,6 +5498,7 @@
           <a:lstStyle/>
           <a:p>
             <a:pPr algn="ctr"/>
+            <a:endParaRPr/>
           </a:p>
         </p:txBody>
       </p:sp>
@@ -5606,6 +5615,7 @@
           <a:lstStyle/>
           <a:p>
             <a:pPr algn="ctr"/>
+            <a:endParaRPr/>
           </a:p>
         </p:txBody>
       </p:sp>
@@ -5722,6 +5732,7 @@
           <a:lstStyle/>
           <a:p>
             <a:pPr algn="ctr"/>
+            <a:endParaRPr/>
           </a:p>
         </p:txBody>
       </p:sp>
@@ -5838,6 +5849,7 @@
           <a:lstStyle/>
           <a:p>
             <a:pPr algn="ctr"/>
+            <a:endParaRPr/>
           </a:p>
         </p:txBody>
       </p:sp>
@@ -5955,7 +5967,7 @@
 </file>
 
 <file path=ppt/slides/slide11.xml><?xml version="1.0" encoding="utf-8"?>
-<p:sld xmlns:a="http://schemas.openxmlformats.org/drawingml/2006/main" xmlns:p="http://schemas.openxmlformats.org/presentationml/2006/main" xmlns:r="http://schemas.openxmlformats.org/officeDocument/2006/relationships">
+<p:sld xmlns:a="http://schemas.openxmlformats.org/drawingml/2006/main" xmlns:r="http://schemas.openxmlformats.org/officeDocument/2006/relationships" xmlns:p="http://schemas.openxmlformats.org/presentationml/2006/main">
   <p:cSld>
     <p:bg>
       <p:bgPr>
@@ -5971,7 +5983,14 @@
         <p:cNvGrpSpPr/>
         <p:nvPr/>
       </p:nvGrpSpPr>
-      <p:grpSpPr/>
+      <p:grpSpPr>
+        <a:xfrm>
+          <a:off x="0" y="0"/>
+          <a:ext cx="0" cy="0"/>
+          <a:chOff x="0" y="0"/>
+          <a:chExt cx="0" cy="0"/>
+        </a:xfrm>
+      </p:grpSpPr>
       <p:sp>
         <p:nvSpPr>
           <p:cNvPr id="2" name="Rectangle 1"/>
@@ -6013,6 +6032,7 @@
           <a:lstStyle/>
           <a:p>
             <a:pPr algn="ctr"/>
+            <a:endParaRPr/>
           </a:p>
         </p:txBody>
       </p:sp>
@@ -6057,6 +6077,7 @@
           <a:lstStyle/>
           <a:p>
             <a:pPr algn="ctr"/>
+            <a:endParaRPr/>
           </a:p>
         </p:txBody>
       </p:sp>
@@ -6101,6 +6122,7 @@
           <a:lstStyle/>
           <a:p>
             <a:pPr algn="ctr"/>
+            <a:endParaRPr/>
           </a:p>
         </p:txBody>
       </p:sp>
@@ -6215,6 +6237,7 @@
           <a:lstStyle/>
           <a:p>
             <a:pPr algn="ctr"/>
+            <a:endParaRPr/>
           </a:p>
         </p:txBody>
       </p:sp>
@@ -6261,6 +6284,7 @@
           <a:lstStyle/>
           <a:p>
             <a:pPr algn="ctr"/>
+            <a:endParaRPr/>
           </a:p>
         </p:txBody>
       </p:sp>
@@ -6305,6 +6329,7 @@
           <a:lstStyle/>
           <a:p>
             <a:pPr algn="ctr"/>
+            <a:endParaRPr/>
           </a:p>
         </p:txBody>
       </p:sp>
@@ -6456,6 +6481,7 @@
           <a:lstStyle/>
           <a:p>
             <a:pPr algn="ctr"/>
+            <a:endParaRPr/>
           </a:p>
         </p:txBody>
       </p:sp>
@@ -6500,6 +6526,7 @@
           <a:lstStyle/>
           <a:p>
             <a:pPr algn="ctr"/>
+            <a:endParaRPr/>
           </a:p>
         </p:txBody>
       </p:sp>
@@ -6651,6 +6678,7 @@
           <a:lstStyle/>
           <a:p>
             <a:pPr algn="ctr"/>
+            <a:endParaRPr/>
           </a:p>
         </p:txBody>
       </p:sp>
@@ -6695,6 +6723,7 @@
           <a:lstStyle/>
           <a:p>
             <a:pPr algn="ctr"/>
+            <a:endParaRPr/>
           </a:p>
         </p:txBody>
       </p:sp>
@@ -6846,6 +6875,7 @@
           <a:lstStyle/>
           <a:p>
             <a:pPr algn="ctr"/>
+            <a:endParaRPr/>
           </a:p>
         </p:txBody>
       </p:sp>
@@ -6890,6 +6920,7 @@
           <a:lstStyle/>
           <a:p>
             <a:pPr algn="ctr"/>
+            <a:endParaRPr/>
           </a:p>
         </p:txBody>
       </p:sp>
@@ -7041,6 +7072,7 @@
           <a:lstStyle/>
           <a:p>
             <a:pPr algn="ctr"/>
+            <a:endParaRPr/>
           </a:p>
         </p:txBody>
       </p:sp>
@@ -7085,6 +7117,7 @@
           <a:lstStyle/>
           <a:p>
             <a:pPr algn="ctr"/>
+            <a:endParaRPr/>
           </a:p>
         </p:txBody>
       </p:sp>
@@ -7236,6 +7269,7 @@
           <a:lstStyle/>
           <a:p>
             <a:pPr algn="ctr"/>
+            <a:endParaRPr/>
           </a:p>
         </p:txBody>
       </p:sp>
@@ -7280,6 +7314,7 @@
           <a:lstStyle/>
           <a:p>
             <a:pPr algn="ctr"/>
+            <a:endParaRPr/>
           </a:p>
         </p:txBody>
       </p:sp>
@@ -7431,6 +7466,7 @@
           <a:lstStyle/>
           <a:p>
             <a:pPr algn="ctr"/>
+            <a:endParaRPr/>
           </a:p>
         </p:txBody>
       </p:sp>
@@ -7475,6 +7511,7 @@
           <a:lstStyle/>
           <a:p>
             <a:pPr algn="ctr"/>
+            <a:endParaRPr/>
           </a:p>
         </p:txBody>
       </p:sp>
@@ -7626,6 +7663,7 @@
           <a:lstStyle/>
           <a:p>
             <a:pPr algn="ctr"/>
+            <a:endParaRPr/>
           </a:p>
         </p:txBody>
       </p:sp>
@@ -7670,6 +7708,7 @@
           <a:lstStyle/>
           <a:p>
             <a:pPr algn="ctr"/>
+            <a:endParaRPr/>
           </a:p>
         </p:txBody>
       </p:sp>
@@ -7821,6 +7860,7 @@
           <a:lstStyle/>
           <a:p>
             <a:pPr algn="ctr"/>
+            <a:endParaRPr/>
           </a:p>
         </p:txBody>
       </p:sp>
@@ -7865,6 +7905,7 @@
           <a:lstStyle/>
           <a:p>
             <a:pPr algn="ctr"/>
+            <a:endParaRPr/>
           </a:p>
         </p:txBody>
       </p:sp>
@@ -8016,6 +8057,7 @@
           <a:lstStyle/>
           <a:p>
             <a:pPr algn="ctr"/>
+            <a:endParaRPr/>
           </a:p>
         </p:txBody>
       </p:sp>
@@ -8060,6 +8102,7 @@
           <a:lstStyle/>
           <a:p>
             <a:pPr algn="ctr"/>
+            <a:endParaRPr/>
           </a:p>
         </p:txBody>
       </p:sp>
@@ -8211,6 +8254,7 @@
           <a:lstStyle/>
           <a:p>
             <a:pPr algn="ctr"/>
+            <a:endParaRPr/>
           </a:p>
         </p:txBody>
       </p:sp>
@@ -8255,6 +8299,7 @@
           <a:lstStyle/>
           <a:p>
             <a:pPr algn="ctr"/>
+            <a:endParaRPr/>
           </a:p>
         </p:txBody>
       </p:sp>
@@ -8406,6 +8451,7 @@
           <a:lstStyle/>
           <a:p>
             <a:pPr algn="ctr"/>
+            <a:endParaRPr/>
           </a:p>
         </p:txBody>
       </p:sp>
@@ -8450,6 +8496,7 @@
           <a:lstStyle/>
           <a:p>
             <a:pPr algn="ctr"/>
+            <a:endParaRPr/>
           </a:p>
         </p:txBody>
       </p:sp>
@@ -8599,6 +8646,7 @@
           <a:lstStyle/>
           <a:p>
             <a:pPr algn="ctr"/>
+            <a:endParaRPr/>
           </a:p>
         </p:txBody>
       </p:sp>
@@ -8645,6 +8693,7 @@
           <a:lstStyle/>
           <a:p>
             <a:pPr algn="ctr"/>
+            <a:endParaRPr/>
           </a:p>
         </p:txBody>
       </p:sp>
@@ -8727,7 +8776,7 @@
 </file>
 
 <file path=ppt/slides/slide12.xml><?xml version="1.0" encoding="utf-8"?>
-<p:sld xmlns:a="http://schemas.openxmlformats.org/drawingml/2006/main" xmlns:p="http://schemas.openxmlformats.org/presentationml/2006/main" xmlns:r="http://schemas.openxmlformats.org/officeDocument/2006/relationships">
+<p:sld xmlns:a="http://schemas.openxmlformats.org/drawingml/2006/main" xmlns:r="http://schemas.openxmlformats.org/officeDocument/2006/relationships" xmlns:p="http://schemas.openxmlformats.org/presentationml/2006/main">
   <p:cSld>
     <p:bg>
       <p:bgPr>
@@ -8743,7 +8792,14 @@
         <p:cNvGrpSpPr/>
         <p:nvPr/>
       </p:nvGrpSpPr>
-      <p:grpSpPr/>
+      <p:grpSpPr>
+        <a:xfrm>
+          <a:off x="0" y="0"/>
+          <a:ext cx="0" cy="0"/>
+          <a:chOff x="0" y="0"/>
+          <a:chExt cx="0" cy="0"/>
+        </a:xfrm>
+      </p:grpSpPr>
       <p:sp>
         <p:nvSpPr>
           <p:cNvPr id="2" name="Rectangle 1"/>
@@ -8785,6 +8841,7 @@
           <a:lstStyle/>
           <a:p>
             <a:pPr algn="ctr"/>
+            <a:endParaRPr/>
           </a:p>
         </p:txBody>
       </p:sp>
@@ -8829,6 +8886,7 @@
           <a:lstStyle/>
           <a:p>
             <a:pPr algn="ctr"/>
+            <a:endParaRPr/>
           </a:p>
         </p:txBody>
       </p:sp>
@@ -8873,6 +8931,7 @@
           <a:lstStyle/>
           <a:p>
             <a:pPr algn="ctr"/>
+            <a:endParaRPr/>
           </a:p>
         </p:txBody>
       </p:sp>
@@ -8987,6 +9046,7 @@
           <a:lstStyle/>
           <a:p>
             <a:pPr algn="ctr"/>
+            <a:endParaRPr/>
           </a:p>
         </p:txBody>
       </p:sp>
@@ -9033,6 +9093,7 @@
           <a:lstStyle/>
           <a:p>
             <a:pPr algn="ctr"/>
+            <a:endParaRPr/>
           </a:p>
         </p:txBody>
       </p:sp>
@@ -9077,6 +9138,7 @@
           <a:lstStyle/>
           <a:p>
             <a:pPr algn="ctr"/>
+            <a:endParaRPr/>
           </a:p>
         </p:txBody>
       </p:sp>
@@ -9262,6 +9324,7 @@
           <a:lstStyle/>
           <a:p>
             <a:pPr algn="ctr"/>
+            <a:endParaRPr/>
           </a:p>
         </p:txBody>
       </p:sp>
@@ -9343,6 +9406,7 @@
           <a:lstStyle/>
           <a:p>
             <a:pPr algn="ctr"/>
+            <a:endParaRPr/>
           </a:p>
         </p:txBody>
       </p:sp>
@@ -9387,6 +9451,7 @@
           <a:lstStyle/>
           <a:p>
             <a:pPr algn="ctr"/>
+            <a:endParaRPr/>
           </a:p>
         </p:txBody>
       </p:sp>
@@ -9572,6 +9637,7 @@
           <a:lstStyle/>
           <a:p>
             <a:pPr algn="ctr"/>
+            <a:endParaRPr/>
           </a:p>
         </p:txBody>
       </p:sp>
@@ -9653,6 +9719,7 @@
           <a:lstStyle/>
           <a:p>
             <a:pPr algn="ctr"/>
+            <a:endParaRPr/>
           </a:p>
         </p:txBody>
       </p:sp>
@@ -9697,6 +9764,7 @@
           <a:lstStyle/>
           <a:p>
             <a:pPr algn="ctr"/>
+            <a:endParaRPr/>
           </a:p>
         </p:txBody>
       </p:sp>
@@ -9882,6 +9950,7 @@
           <a:lstStyle/>
           <a:p>
             <a:pPr algn="ctr"/>
+            <a:endParaRPr/>
           </a:p>
         </p:txBody>
       </p:sp>
@@ -9963,6 +10032,7 @@
           <a:lstStyle/>
           <a:p>
             <a:pPr algn="ctr"/>
+            <a:endParaRPr/>
           </a:p>
         </p:txBody>
       </p:sp>
@@ -10007,6 +10077,7 @@
           <a:lstStyle/>
           <a:p>
             <a:pPr algn="ctr"/>
+            <a:endParaRPr/>
           </a:p>
         </p:txBody>
       </p:sp>
@@ -10192,6 +10263,7 @@
           <a:lstStyle/>
           <a:p>
             <a:pPr algn="ctr"/>
+            <a:endParaRPr/>
           </a:p>
         </p:txBody>
       </p:sp>
@@ -10273,6 +10345,7 @@
           <a:lstStyle/>
           <a:p>
             <a:pPr algn="ctr"/>
+            <a:endParaRPr/>
           </a:p>
         </p:txBody>
       </p:sp>
@@ -10317,6 +10390,7 @@
           <a:lstStyle/>
           <a:p>
             <a:pPr algn="ctr"/>
+            <a:endParaRPr/>
           </a:p>
         </p:txBody>
       </p:sp>
@@ -10502,6 +10576,7 @@
           <a:lstStyle/>
           <a:p>
             <a:pPr algn="ctr"/>
+            <a:endParaRPr/>
           </a:p>
         </p:txBody>
       </p:sp>
@@ -10583,6 +10658,7 @@
           <a:lstStyle/>
           <a:p>
             <a:pPr algn="ctr"/>
+            <a:endParaRPr/>
           </a:p>
         </p:txBody>
       </p:sp>
@@ -10664,6 +10740,7 @@
           <a:lstStyle/>
           <a:p>
             <a:pPr algn="ctr"/>
+            <a:endParaRPr/>
           </a:p>
         </p:txBody>
       </p:sp>
@@ -10708,6 +10785,7 @@
           <a:lstStyle/>
           <a:p>
             <a:pPr algn="ctr"/>
+            <a:endParaRPr/>
           </a:p>
         </p:txBody>
       </p:sp>
@@ -10893,6 +10971,7 @@
           <a:lstStyle/>
           <a:p>
             <a:pPr algn="ctr"/>
+            <a:endParaRPr/>
           </a:p>
         </p:txBody>
       </p:sp>
@@ -10974,6 +11053,7 @@
           <a:lstStyle/>
           <a:p>
             <a:pPr algn="ctr"/>
+            <a:endParaRPr/>
           </a:p>
         </p:txBody>
       </p:sp>
@@ -11018,6 +11098,7 @@
           <a:lstStyle/>
           <a:p>
             <a:pPr algn="ctr"/>
+            <a:endParaRPr/>
           </a:p>
         </p:txBody>
       </p:sp>
@@ -11203,6 +11284,7 @@
           <a:lstStyle/>
           <a:p>
             <a:pPr algn="ctr"/>
+            <a:endParaRPr/>
           </a:p>
         </p:txBody>
       </p:sp>
@@ -11284,6 +11366,7 @@
           <a:lstStyle/>
           <a:p>
             <a:pPr algn="ctr"/>
+            <a:endParaRPr/>
           </a:p>
         </p:txBody>
       </p:sp>
@@ -11328,6 +11411,7 @@
           <a:lstStyle/>
           <a:p>
             <a:pPr algn="ctr"/>
+            <a:endParaRPr/>
           </a:p>
         </p:txBody>
       </p:sp>
@@ -11513,6 +11597,7 @@
           <a:lstStyle/>
           <a:p>
             <a:pPr algn="ctr"/>
+            <a:endParaRPr/>
           </a:p>
         </p:txBody>
       </p:sp>
@@ -11590,6 +11675,7 @@
           <a:lstStyle/>
           <a:p>
             <a:pPr algn="ctr"/>
+            <a:endParaRPr/>
           </a:p>
         </p:txBody>
       </p:sp>
@@ -11636,6 +11722,7 @@
           <a:lstStyle/>
           <a:p>
             <a:pPr algn="ctr"/>
+            <a:endParaRPr/>
           </a:p>
         </p:txBody>
       </p:sp>
@@ -11715,6 +11802,7 @@
           <a:lstStyle/>
           <a:p>
             <a:pPr algn="ctr"/>
+            <a:endParaRPr/>
           </a:p>
         </p:txBody>
       </p:sp>
@@ -11762,7 +11850,7 @@
 </file>
 
 <file path=ppt/slides/slide2.xml><?xml version="1.0" encoding="utf-8"?>
-<p:sld xmlns:a="http://schemas.openxmlformats.org/drawingml/2006/main" xmlns:p="http://schemas.openxmlformats.org/presentationml/2006/main" xmlns:r="http://schemas.openxmlformats.org/officeDocument/2006/relationships">
+<p:sld xmlns:a="http://schemas.openxmlformats.org/drawingml/2006/main" xmlns:r="http://schemas.openxmlformats.org/officeDocument/2006/relationships" xmlns:p="http://schemas.openxmlformats.org/presentationml/2006/main">
   <p:cSld>
     <p:bg>
       <p:bgPr>
@@ -11778,7 +11866,14 @@
         <p:cNvGrpSpPr/>
         <p:nvPr/>
       </p:nvGrpSpPr>
-      <p:grpSpPr/>
+      <p:grpSpPr>
+        <a:xfrm>
+          <a:off x="0" y="0"/>
+          <a:ext cx="0" cy="0"/>
+          <a:chOff x="0" y="0"/>
+          <a:chExt cx="0" cy="0"/>
+        </a:xfrm>
+      </p:grpSpPr>
       <p:sp>
         <p:nvSpPr>
           <p:cNvPr id="2" name="Rectangle 1"/>
@@ -11820,6 +11915,7 @@
           <a:lstStyle/>
           <a:p>
             <a:pPr algn="ctr"/>
+            <a:endParaRPr/>
           </a:p>
         </p:txBody>
       </p:sp>
@@ -11864,6 +11960,7 @@
           <a:lstStyle/>
           <a:p>
             <a:pPr algn="ctr"/>
+            <a:endParaRPr/>
           </a:p>
         </p:txBody>
       </p:sp>
@@ -11908,6 +12005,7 @@
           <a:lstStyle/>
           <a:p>
             <a:pPr algn="ctr"/>
+            <a:endParaRPr/>
           </a:p>
         </p:txBody>
       </p:sp>
@@ -12024,6 +12122,7 @@
           <a:lstStyle/>
           <a:p>
             <a:pPr algn="ctr"/>
+            <a:endParaRPr/>
           </a:p>
         </p:txBody>
       </p:sp>
@@ -12175,6 +12274,7 @@
           <a:lstStyle/>
           <a:p>
             <a:pPr algn="ctr"/>
+            <a:endParaRPr/>
           </a:p>
         </p:txBody>
       </p:sp>
@@ -12326,6 +12426,7 @@
           <a:lstStyle/>
           <a:p>
             <a:pPr algn="ctr"/>
+            <a:endParaRPr/>
           </a:p>
         </p:txBody>
       </p:sp>
@@ -12477,6 +12578,7 @@
           <a:lstStyle/>
           <a:p>
             <a:pPr algn="ctr"/>
+            <a:endParaRPr/>
           </a:p>
         </p:txBody>
       </p:sp>
@@ -12628,6 +12730,7 @@
           <a:lstStyle/>
           <a:p>
             <a:pPr algn="ctr"/>
+            <a:endParaRPr/>
           </a:p>
         </p:txBody>
       </p:sp>
@@ -12779,6 +12882,7 @@
           <a:lstStyle/>
           <a:p>
             <a:pPr algn="ctr"/>
+            <a:endParaRPr/>
           </a:p>
         </p:txBody>
       </p:sp>
@@ -12860,6 +12964,7 @@
           <a:lstStyle/>
           <a:p>
             <a:pPr algn="ctr"/>
+            <a:endParaRPr/>
           </a:p>
         </p:txBody>
       </p:sp>
@@ -12942,6 +13047,7 @@
           <a:lstStyle/>
           <a:p>
             <a:pPr algn="ctr"/>
+            <a:endParaRPr/>
           </a:p>
         </p:txBody>
       </p:sp>
@@ -13024,7 +13130,7 @@
 </file>
 
 <file path=ppt/slides/slide3.xml><?xml version="1.0" encoding="utf-8"?>
-<p:sld xmlns:a="http://schemas.openxmlformats.org/drawingml/2006/main" xmlns:p="http://schemas.openxmlformats.org/presentationml/2006/main" xmlns:r="http://schemas.openxmlformats.org/officeDocument/2006/relationships">
+<p:sld xmlns:a="http://schemas.openxmlformats.org/drawingml/2006/main" xmlns:r="http://schemas.openxmlformats.org/officeDocument/2006/relationships" xmlns:p="http://schemas.openxmlformats.org/presentationml/2006/main">
   <p:cSld>
     <p:bg>
       <p:bgPr>
@@ -13040,7 +13146,14 @@
         <p:cNvGrpSpPr/>
         <p:nvPr/>
       </p:nvGrpSpPr>
-      <p:grpSpPr/>
+      <p:grpSpPr>
+        <a:xfrm>
+          <a:off x="0" y="0"/>
+          <a:ext cx="0" cy="0"/>
+          <a:chOff x="0" y="0"/>
+          <a:chExt cx="0" cy="0"/>
+        </a:xfrm>
+      </p:grpSpPr>
       <p:sp>
         <p:nvSpPr>
           <p:cNvPr id="2" name="Rectangle 1"/>
@@ -13082,6 +13195,7 @@
           <a:lstStyle/>
           <a:p>
             <a:pPr algn="ctr"/>
+            <a:endParaRPr/>
           </a:p>
         </p:txBody>
       </p:sp>
@@ -13126,6 +13240,7 @@
           <a:lstStyle/>
           <a:p>
             <a:pPr algn="ctr"/>
+            <a:endParaRPr/>
           </a:p>
         </p:txBody>
       </p:sp>
@@ -13170,6 +13285,7 @@
           <a:lstStyle/>
           <a:p>
             <a:pPr algn="ctr"/>
+            <a:endParaRPr/>
           </a:p>
         </p:txBody>
       </p:sp>
@@ -13286,6 +13402,7 @@
           <a:lstStyle/>
           <a:p>
             <a:pPr algn="ctr"/>
+            <a:endParaRPr/>
           </a:p>
         </p:txBody>
       </p:sp>
@@ -13367,6 +13484,7 @@
           <a:lstStyle/>
           <a:p>
             <a:pPr algn="ctr"/>
+            <a:endParaRPr/>
           </a:p>
         </p:txBody>
       </p:sp>
@@ -13411,6 +13529,7 @@
           <a:lstStyle/>
           <a:p>
             <a:pPr algn="ctr"/>
+            <a:endParaRPr/>
           </a:p>
         </p:txBody>
       </p:sp>
@@ -13562,6 +13681,7 @@
           <a:lstStyle/>
           <a:p>
             <a:pPr algn="ctr"/>
+            <a:endParaRPr/>
           </a:p>
         </p:txBody>
       </p:sp>
@@ -13606,6 +13726,7 @@
           <a:lstStyle/>
           <a:p>
             <a:pPr algn="ctr"/>
+            <a:endParaRPr/>
           </a:p>
         </p:txBody>
       </p:sp>
@@ -13757,6 +13878,7 @@
           <a:lstStyle/>
           <a:p>
             <a:pPr algn="ctr"/>
+            <a:endParaRPr/>
           </a:p>
         </p:txBody>
       </p:sp>
@@ -13801,6 +13923,7 @@
           <a:lstStyle/>
           <a:p>
             <a:pPr algn="ctr"/>
+            <a:endParaRPr/>
           </a:p>
         </p:txBody>
       </p:sp>
@@ -13952,6 +14075,7 @@
           <a:lstStyle/>
           <a:p>
             <a:pPr algn="ctr"/>
+            <a:endParaRPr/>
           </a:p>
         </p:txBody>
       </p:sp>
@@ -13996,6 +14120,7 @@
           <a:lstStyle/>
           <a:p>
             <a:pPr algn="ctr"/>
+            <a:endParaRPr/>
           </a:p>
         </p:txBody>
       </p:sp>
@@ -14147,6 +14272,7 @@
           <a:lstStyle/>
           <a:p>
             <a:pPr algn="ctr"/>
+            <a:endParaRPr/>
           </a:p>
         </p:txBody>
       </p:sp>
@@ -14191,6 +14317,7 @@
           <a:lstStyle/>
           <a:p>
             <a:pPr algn="ctr"/>
+            <a:endParaRPr/>
           </a:p>
         </p:txBody>
       </p:sp>
@@ -14342,6 +14469,7 @@
           <a:lstStyle/>
           <a:p>
             <a:pPr algn="ctr"/>
+            <a:endParaRPr/>
           </a:p>
         </p:txBody>
       </p:sp>
@@ -14386,6 +14514,7 @@
           <a:lstStyle/>
           <a:p>
             <a:pPr algn="ctr"/>
+            <a:endParaRPr/>
           </a:p>
         </p:txBody>
       </p:sp>
@@ -14537,6 +14666,7 @@
           <a:lstStyle/>
           <a:p>
             <a:pPr algn="ctr"/>
+            <a:endParaRPr/>
           </a:p>
         </p:txBody>
       </p:sp>
@@ -14619,7 +14749,7 @@
 </file>
 
 <file path=ppt/slides/slide4.xml><?xml version="1.0" encoding="utf-8"?>
-<p:sld xmlns:a="http://schemas.openxmlformats.org/drawingml/2006/main" xmlns:p="http://schemas.openxmlformats.org/presentationml/2006/main" xmlns:r="http://schemas.openxmlformats.org/officeDocument/2006/relationships">
+<p:sld xmlns:a="http://schemas.openxmlformats.org/drawingml/2006/main" xmlns:r="http://schemas.openxmlformats.org/officeDocument/2006/relationships" xmlns:p="http://schemas.openxmlformats.org/presentationml/2006/main">
   <p:cSld>
     <p:bg>
       <p:bgPr>
@@ -14635,7 +14765,14 @@
         <p:cNvGrpSpPr/>
         <p:nvPr/>
       </p:nvGrpSpPr>
-      <p:grpSpPr/>
+      <p:grpSpPr>
+        <a:xfrm>
+          <a:off x="0" y="0"/>
+          <a:ext cx="0" cy="0"/>
+          <a:chOff x="0" y="0"/>
+          <a:chExt cx="0" cy="0"/>
+        </a:xfrm>
+      </p:grpSpPr>
       <p:sp>
         <p:nvSpPr>
           <p:cNvPr id="2" name="Rectangle 1"/>
@@ -14677,6 +14814,7 @@
           <a:lstStyle/>
           <a:p>
             <a:pPr algn="ctr"/>
+            <a:endParaRPr/>
           </a:p>
         </p:txBody>
       </p:sp>
@@ -14721,6 +14859,7 @@
           <a:lstStyle/>
           <a:p>
             <a:pPr algn="ctr"/>
+            <a:endParaRPr/>
           </a:p>
         </p:txBody>
       </p:sp>
@@ -14765,6 +14904,7 @@
           <a:lstStyle/>
           <a:p>
             <a:pPr algn="ctr"/>
+            <a:endParaRPr/>
           </a:p>
         </p:txBody>
       </p:sp>
@@ -14881,6 +15021,7 @@
           <a:lstStyle/>
           <a:p>
             <a:pPr algn="ctr"/>
+            <a:endParaRPr/>
           </a:p>
         </p:txBody>
       </p:sp>
@@ -14962,6 +15103,7 @@
           <a:lstStyle/>
           <a:p>
             <a:pPr algn="ctr"/>
+            <a:endParaRPr/>
           </a:p>
         </p:txBody>
       </p:sp>
@@ -15043,8 +15185,8 @@
         </p:nvCxnSpPr>
         <p:spPr>
           <a:xfrm>
-            <a:off x="1874520" y="1499616.0"/>
-            <a:ext cx="210311" cy="0.0"/>
+            <a:off x="1874520" y="0"/>
+            <a:ext cx="210311" cy="0"/>
           </a:xfrm>
           <a:prstGeom prst="line">
             <a:avLst/>
@@ -15150,6 +15292,7 @@
           <a:lstStyle/>
           <a:p>
             <a:pPr algn="ctr"/>
+            <a:endParaRPr/>
           </a:p>
         </p:txBody>
       </p:sp>
@@ -15194,6 +15337,7 @@
           <a:lstStyle/>
           <a:p>
             <a:pPr algn="ctr"/>
+            <a:endParaRPr/>
           </a:p>
         </p:txBody>
       </p:sp>
@@ -15415,6 +15559,7 @@
           <a:lstStyle/>
           <a:p>
             <a:pPr algn="ctr"/>
+            <a:endParaRPr/>
           </a:p>
         </p:txBody>
       </p:sp>
@@ -15498,8 +15643,8 @@
         </p:nvCxnSpPr>
         <p:spPr>
           <a:xfrm>
-            <a:off x="4919471" y="1444752.0"/>
-            <a:ext cx="201169" cy="54864.0"/>
+            <a:off x="4919471" y="0"/>
+            <a:ext cx="201169" cy="0"/>
           </a:xfrm>
           <a:prstGeom prst="line">
             <a:avLst/>
@@ -15570,6 +15715,7 @@
           <a:lstStyle/>
           <a:p>
             <a:pPr algn="ctr"/>
+            <a:endParaRPr/>
           </a:p>
         </p:txBody>
       </p:sp>
@@ -15651,6 +15797,7 @@
           <a:lstStyle/>
           <a:p>
             <a:pPr algn="ctr"/>
+            <a:endParaRPr/>
           </a:p>
         </p:txBody>
       </p:sp>
@@ -15695,6 +15842,7 @@
           <a:lstStyle/>
           <a:p>
             <a:pPr algn="ctr"/>
+            <a:endParaRPr/>
           </a:p>
         </p:txBody>
       </p:sp>
@@ -15776,6 +15924,7 @@
           <a:lstStyle/>
           <a:p>
             <a:pPr algn="ctr"/>
+            <a:endParaRPr/>
           </a:p>
         </p:txBody>
       </p:sp>
@@ -15857,6 +16006,7 @@
           <a:lstStyle/>
           <a:p>
             <a:pPr algn="ctr"/>
+            <a:endParaRPr/>
           </a:p>
         </p:txBody>
       </p:sp>
@@ -15938,6 +16088,7 @@
           <a:lstStyle/>
           <a:p>
             <a:pPr algn="ctr"/>
+            <a:endParaRPr/>
           </a:p>
         </p:txBody>
       </p:sp>
@@ -16019,6 +16170,7 @@
           <a:lstStyle/>
           <a:p>
             <a:pPr algn="ctr"/>
+            <a:endParaRPr/>
           </a:p>
         </p:txBody>
       </p:sp>
@@ -16100,6 +16252,7 @@
           <a:lstStyle/>
           <a:p>
             <a:pPr algn="ctr"/>
+            <a:endParaRPr/>
           </a:p>
         </p:txBody>
       </p:sp>
@@ -16181,6 +16334,7 @@
           <a:lstStyle/>
           <a:p>
             <a:pPr algn="ctr"/>
+            <a:endParaRPr/>
           </a:p>
         </p:txBody>
       </p:sp>
@@ -16262,6 +16416,7 @@
           <a:lstStyle/>
           <a:p>
             <a:pPr algn="ctr"/>
+            <a:endParaRPr/>
           </a:p>
         </p:txBody>
       </p:sp>
@@ -16343,6 +16498,7 @@
           <a:lstStyle/>
           <a:p>
             <a:pPr algn="ctr"/>
+            <a:endParaRPr/>
           </a:p>
         </p:txBody>
       </p:sp>
@@ -16424,6 +16580,7 @@
           <a:lstStyle/>
           <a:p>
             <a:pPr algn="ctr"/>
+            <a:endParaRPr/>
           </a:p>
         </p:txBody>
       </p:sp>
@@ -16540,6 +16697,7 @@
           <a:lstStyle/>
           <a:p>
             <a:pPr algn="ctr"/>
+            <a:endParaRPr/>
           </a:p>
         </p:txBody>
       </p:sp>
@@ -16584,6 +16742,7 @@
           <a:lstStyle/>
           <a:p>
             <a:pPr algn="ctr"/>
+            <a:endParaRPr/>
           </a:p>
         </p:txBody>
       </p:sp>
@@ -16665,6 +16824,7 @@
           <a:lstStyle/>
           <a:p>
             <a:pPr algn="ctr"/>
+            <a:endParaRPr/>
           </a:p>
         </p:txBody>
       </p:sp>
@@ -16746,6 +16906,7 @@
           <a:lstStyle/>
           <a:p>
             <a:pPr algn="ctr"/>
+            <a:endParaRPr/>
           </a:p>
         </p:txBody>
       </p:sp>
@@ -16827,6 +16988,7 @@
           <a:lstStyle/>
           <a:p>
             <a:pPr algn="ctr"/>
+            <a:endParaRPr/>
           </a:p>
         </p:txBody>
       </p:sp>
@@ -16976,6 +17138,7 @@
           <a:lstStyle/>
           <a:p>
             <a:pPr algn="ctr"/>
+            <a:endParaRPr/>
           </a:p>
         </p:txBody>
       </p:sp>
@@ -17056,6 +17219,7 @@
           <a:lstStyle/>
           <a:p>
             <a:pPr algn="ctr"/>
+            <a:endParaRPr/>
           </a:p>
         </p:txBody>
       </p:sp>
@@ -17067,8 +17231,8 @@
         </p:nvCxnSpPr>
         <p:spPr>
           <a:xfrm>
-            <a:off x="2468880.0" y="3712464"/>
-            <a:ext cx="0.0" cy="201168"/>
+            <a:off x="0" y="3712464"/>
+            <a:ext cx="0" cy="201168"/>
           </a:xfrm>
           <a:prstGeom prst="line">
             <a:avLst/>
@@ -17104,8 +17268,8 @@
         </p:nvCxnSpPr>
         <p:spPr>
           <a:xfrm flipH="1">
-            <a:off x="1609344.0" y="2084832"/>
-            <a:ext cx="1892807.0" cy="54864"/>
+            <a:off x="0" y="2084832"/>
+            <a:ext cx="0" cy="54864"/>
           </a:xfrm>
           <a:prstGeom prst="line">
             <a:avLst/>
@@ -17141,8 +17305,8 @@
         </p:nvCxnSpPr>
         <p:spPr>
           <a:xfrm flipH="1" flipV="1">
-            <a:off x="4069079.0" y="2084832"/>
-            <a:ext cx="5715001.0" cy="54864"/>
+            <a:off x="0" y="2084832"/>
+            <a:ext cx="0" cy="54864"/>
           </a:xfrm>
           <a:prstGeom prst="line">
             <a:avLst/>
@@ -17213,6 +17377,7 @@
           <a:lstStyle/>
           <a:p>
             <a:pPr algn="ctr"/>
+            <a:endParaRPr/>
           </a:p>
         </p:txBody>
       </p:sp>
@@ -17294,6 +17459,7 @@
           <a:lstStyle/>
           <a:p>
             <a:pPr algn="ctr"/>
+            <a:endParaRPr/>
           </a:p>
         </p:txBody>
       </p:sp>
@@ -17338,6 +17504,7 @@
           <a:lstStyle/>
           <a:p>
             <a:pPr algn="ctr"/>
+            <a:endParaRPr/>
           </a:p>
         </p:txBody>
       </p:sp>
@@ -17419,8 +17586,8 @@
         </p:nvCxnSpPr>
         <p:spPr>
           <a:xfrm flipH="1">
-            <a:off x="963930.0" y="2130552"/>
-            <a:ext cx="2254757.0" cy="2002536"/>
+            <a:off x="0" y="2130552"/>
+            <a:ext cx="0" cy="2002536"/>
           </a:xfrm>
           <a:prstGeom prst="line">
             <a:avLst/>
@@ -17456,8 +17623,8 @@
         </p:nvCxnSpPr>
         <p:spPr>
           <a:xfrm flipV="1">
-            <a:off x="963930.0" y="3822192"/>
-            <a:ext cx="215646.0" cy="310896"/>
+            <a:off x="0" y="3822192"/>
+            <a:ext cx="0" cy="310896"/>
           </a:xfrm>
           <a:prstGeom prst="line">
             <a:avLst/>
@@ -17528,6 +17695,7 @@
           <a:lstStyle/>
           <a:p>
             <a:pPr algn="ctr"/>
+            <a:endParaRPr/>
           </a:p>
         </p:txBody>
       </p:sp>
@@ -17572,6 +17740,7 @@
           <a:lstStyle/>
           <a:p>
             <a:pPr algn="ctr"/>
+            <a:endParaRPr/>
           </a:p>
         </p:txBody>
       </p:sp>
@@ -17653,8 +17822,8 @@
         </p:nvCxnSpPr>
         <p:spPr>
           <a:xfrm flipH="1">
-            <a:off x="2306574.0" y="2130552"/>
-            <a:ext cx="1195577.0" cy="2002536"/>
+            <a:off x="0" y="2130552"/>
+            <a:ext cx="0" cy="2002536"/>
           </a:xfrm>
           <a:prstGeom prst="line">
             <a:avLst/>
@@ -17690,8 +17859,8 @@
         </p:nvCxnSpPr>
         <p:spPr>
           <a:xfrm flipH="1" flipV="1">
-            <a:off x="1523390.4" y="3822192"/>
-            <a:ext cx="783183.6000000001" cy="310896"/>
+            <a:off x="0" y="3822192"/>
+            <a:ext cx="0" cy="310896"/>
           </a:xfrm>
           <a:prstGeom prst="line">
             <a:avLst/>
@@ -17762,6 +17931,7 @@
           <a:lstStyle/>
           <a:p>
             <a:pPr algn="ctr"/>
+            <a:endParaRPr/>
           </a:p>
         </p:txBody>
       </p:sp>
@@ -17806,6 +17976,7 @@
           <a:lstStyle/>
           <a:p>
             <a:pPr algn="ctr"/>
+            <a:endParaRPr/>
           </a:p>
         </p:txBody>
       </p:sp>
@@ -17887,8 +18058,8 @@
         </p:nvCxnSpPr>
         <p:spPr>
           <a:xfrm flipH="1">
-            <a:off x="3649218.0" y="2130552"/>
-            <a:ext cx="136397.0" cy="2002536"/>
+            <a:off x="0" y="2130552"/>
+            <a:ext cx="0" cy="2002536"/>
           </a:xfrm>
           <a:prstGeom prst="line">
             <a:avLst/>
@@ -17924,8 +18095,8 @@
         </p:nvCxnSpPr>
         <p:spPr>
           <a:xfrm flipH="1" flipV="1">
-            <a:off x="1867204.8" y="3822192"/>
-            <a:ext cx="1782013.2" cy="310896"/>
+            <a:off x="0" y="3822192"/>
+            <a:ext cx="0" cy="310896"/>
           </a:xfrm>
           <a:prstGeom prst="line">
             <a:avLst/>
@@ -17996,6 +18167,7 @@
           <a:lstStyle/>
           <a:p>
             <a:pPr algn="ctr"/>
+            <a:endParaRPr/>
           </a:p>
         </p:txBody>
       </p:sp>
@@ -18040,6 +18212,7 @@
           <a:lstStyle/>
           <a:p>
             <a:pPr algn="ctr"/>
+            <a:endParaRPr/>
           </a:p>
         </p:txBody>
       </p:sp>
@@ -18121,8 +18294,8 @@
         </p:nvCxnSpPr>
         <p:spPr>
           <a:xfrm>
-            <a:off x="4069079.0" y="2130552"/>
-            <a:ext cx="922783.0" cy="2002536"/>
+            <a:off x="0" y="2130552"/>
+            <a:ext cx="0" cy="2002536"/>
           </a:xfrm>
           <a:prstGeom prst="line">
             <a:avLst/>
@@ -18158,8 +18331,8 @@
         </p:nvCxnSpPr>
         <p:spPr>
           <a:xfrm flipH="1" flipV="1">
-            <a:off x="2211019.2" y="3822192"/>
-            <a:ext cx="2780842.8" cy="310896"/>
+            <a:off x="0" y="3822192"/>
+            <a:ext cx="0" cy="310896"/>
           </a:xfrm>
           <a:prstGeom prst="line">
             <a:avLst/>
@@ -18230,6 +18403,7 @@
           <a:lstStyle/>
           <a:p>
             <a:pPr algn="ctr"/>
+            <a:endParaRPr/>
           </a:p>
         </p:txBody>
       </p:sp>
@@ -18274,6 +18448,7 @@
           <a:lstStyle/>
           <a:p>
             <a:pPr algn="ctr"/>
+            <a:endParaRPr/>
           </a:p>
         </p:txBody>
       </p:sp>
@@ -18355,8 +18530,8 @@
         </p:nvCxnSpPr>
         <p:spPr>
           <a:xfrm>
-            <a:off x="4352543.0" y="2130552"/>
-            <a:ext cx="1981963.0" cy="2002536"/>
+            <a:off x="0" y="2130552"/>
+            <a:ext cx="0" cy="2002536"/>
           </a:xfrm>
           <a:prstGeom prst="line">
             <a:avLst/>
@@ -18392,8 +18567,8 @@
         </p:nvCxnSpPr>
         <p:spPr>
           <a:xfrm flipH="1" flipV="1">
-            <a:off x="2554833.6" y="3822192"/>
-            <a:ext cx="3779672.4" cy="310896"/>
+            <a:off x="0" y="3822192"/>
+            <a:ext cx="0" cy="310896"/>
           </a:xfrm>
           <a:prstGeom prst="line">
             <a:avLst/>
@@ -18464,6 +18639,7 @@
           <a:lstStyle/>
           <a:p>
             <a:pPr algn="ctr"/>
+            <a:endParaRPr/>
           </a:p>
         </p:txBody>
       </p:sp>
@@ -18508,6 +18684,7 @@
           <a:lstStyle/>
           <a:p>
             <a:pPr algn="ctr"/>
+            <a:endParaRPr/>
           </a:p>
         </p:txBody>
       </p:sp>
@@ -18589,8 +18766,8 @@
         </p:nvCxnSpPr>
         <p:spPr>
           <a:xfrm>
-            <a:off x="4636007.0" y="2130552"/>
-            <a:ext cx="3041143.0" cy="2002536"/>
+            <a:off x="0" y="2130552"/>
+            <a:ext cx="0" cy="2002536"/>
           </a:xfrm>
           <a:prstGeom prst="line">
             <a:avLst/>
@@ -18661,6 +18838,7 @@
           <a:lstStyle/>
           <a:p>
             <a:pPr algn="ctr"/>
+            <a:endParaRPr/>
           </a:p>
         </p:txBody>
       </p:sp>
@@ -18705,6 +18883,7 @@
           <a:lstStyle/>
           <a:p>
             <a:pPr algn="ctr"/>
+            <a:endParaRPr/>
           </a:p>
         </p:txBody>
       </p:sp>
@@ -18786,6 +18965,7 @@
           <a:lstStyle/>
           <a:p>
             <a:pPr algn="ctr"/>
+            <a:endParaRPr/>
           </a:p>
         </p:txBody>
       </p:sp>
@@ -18830,6 +19010,7 @@
           <a:lstStyle/>
           <a:p>
             <a:pPr algn="ctr"/>
+            <a:endParaRPr/>
           </a:p>
         </p:txBody>
       </p:sp>
@@ -18981,6 +19162,7 @@
           <a:lstStyle/>
           <a:p>
             <a:pPr algn="ctr"/>
+            <a:endParaRPr/>
           </a:p>
         </p:txBody>
       </p:sp>
@@ -19025,6 +19207,7 @@
           <a:lstStyle/>
           <a:p>
             <a:pPr algn="ctr"/>
+            <a:endParaRPr/>
           </a:p>
         </p:txBody>
       </p:sp>
@@ -19176,6 +19359,7 @@
           <a:lstStyle/>
           <a:p>
             <a:pPr algn="ctr"/>
+            <a:endParaRPr/>
           </a:p>
         </p:txBody>
       </p:sp>
@@ -19220,6 +19404,7 @@
           <a:lstStyle/>
           <a:p>
             <a:pPr algn="ctr"/>
+            <a:endParaRPr/>
           </a:p>
         </p:txBody>
       </p:sp>
@@ -19372,7 +19557,7 @@
 </file>
 
 <file path=ppt/slides/slide5.xml><?xml version="1.0" encoding="utf-8"?>
-<p:sld xmlns:a="http://schemas.openxmlformats.org/drawingml/2006/main" xmlns:p="http://schemas.openxmlformats.org/presentationml/2006/main" xmlns:r="http://schemas.openxmlformats.org/officeDocument/2006/relationships">
+<p:sld xmlns:a="http://schemas.openxmlformats.org/drawingml/2006/main" xmlns:r="http://schemas.openxmlformats.org/officeDocument/2006/relationships" xmlns:p="http://schemas.openxmlformats.org/presentationml/2006/main">
   <p:cSld>
     <p:bg>
       <p:bgPr>
@@ -19388,7 +19573,14 @@
         <p:cNvGrpSpPr/>
         <p:nvPr/>
       </p:nvGrpSpPr>
-      <p:grpSpPr/>
+      <p:grpSpPr>
+        <a:xfrm>
+          <a:off x="0" y="0"/>
+          <a:ext cx="0" cy="0"/>
+          <a:chOff x="0" y="0"/>
+          <a:chExt cx="0" cy="0"/>
+        </a:xfrm>
+      </p:grpSpPr>
       <p:sp>
         <p:nvSpPr>
           <p:cNvPr id="2" name="Rectangle 1"/>
@@ -19430,6 +19622,7 @@
           <a:lstStyle/>
           <a:p>
             <a:pPr algn="ctr"/>
+            <a:endParaRPr/>
           </a:p>
         </p:txBody>
       </p:sp>
@@ -19474,6 +19667,7 @@
           <a:lstStyle/>
           <a:p>
             <a:pPr algn="ctr"/>
+            <a:endParaRPr/>
           </a:p>
         </p:txBody>
       </p:sp>
@@ -19518,6 +19712,7 @@
           <a:lstStyle/>
           <a:p>
             <a:pPr algn="ctr"/>
+            <a:endParaRPr/>
           </a:p>
         </p:txBody>
       </p:sp>
@@ -19634,6 +19829,7 @@
           <a:lstStyle/>
           <a:p>
             <a:pPr algn="ctr"/>
+            <a:endParaRPr/>
           </a:p>
         </p:txBody>
       </p:sp>
@@ -19750,6 +19946,7 @@
           <a:lstStyle/>
           <a:p>
             <a:pPr algn="ctr"/>
+            <a:endParaRPr/>
           </a:p>
         </p:txBody>
       </p:sp>
@@ -19866,6 +20063,7 @@
           <a:lstStyle/>
           <a:p>
             <a:pPr algn="ctr"/>
+            <a:endParaRPr/>
           </a:p>
         </p:txBody>
       </p:sp>
@@ -19910,6 +20108,7 @@
           <a:lstStyle/>
           <a:p>
             <a:pPr algn="ctr"/>
+            <a:endParaRPr/>
           </a:p>
         </p:txBody>
       </p:sp>
@@ -20175,6 +20374,7 @@
           <a:lstStyle/>
           <a:p>
             <a:pPr algn="ctr"/>
+            <a:endParaRPr/>
           </a:p>
         </p:txBody>
       </p:sp>
@@ -20291,6 +20491,7 @@
           <a:lstStyle/>
           <a:p>
             <a:pPr algn="ctr"/>
+            <a:endParaRPr/>
           </a:p>
         </p:txBody>
       </p:sp>
@@ -20407,6 +20608,7 @@
           <a:lstStyle/>
           <a:p>
             <a:pPr algn="ctr"/>
+            <a:endParaRPr/>
           </a:p>
         </p:txBody>
       </p:sp>
@@ -20523,6 +20725,7 @@
           <a:lstStyle/>
           <a:p>
             <a:pPr algn="ctr"/>
+            <a:endParaRPr/>
           </a:p>
         </p:txBody>
       </p:sp>
@@ -20639,6 +20842,7 @@
           <a:lstStyle/>
           <a:p>
             <a:pPr algn="ctr"/>
+            <a:endParaRPr/>
           </a:p>
         </p:txBody>
       </p:sp>
@@ -20755,6 +20959,7 @@
           <a:lstStyle/>
           <a:p>
             <a:pPr algn="ctr"/>
+            <a:endParaRPr/>
           </a:p>
         </p:txBody>
       </p:sp>
@@ -20871,6 +21076,7 @@
           <a:lstStyle/>
           <a:p>
             <a:pPr algn="ctr"/>
+            <a:endParaRPr/>
           </a:p>
         </p:txBody>
       </p:sp>
@@ -20987,6 +21193,7 @@
           <a:lstStyle/>
           <a:p>
             <a:pPr algn="ctr"/>
+            <a:endParaRPr/>
           </a:p>
         </p:txBody>
       </p:sp>
@@ -21103,6 +21310,7 @@
           <a:lstStyle/>
           <a:p>
             <a:pPr algn="ctr"/>
+            <a:endParaRPr/>
           </a:p>
         </p:txBody>
       </p:sp>
@@ -21184,8 +21392,8 @@
         </p:nvCxnSpPr>
         <p:spPr>
           <a:xfrm>
-            <a:off x="1371600" y="1773936.0"/>
-            <a:ext cx="0" cy="237744.0"/>
+            <a:off x="1371600" y="0"/>
+            <a:ext cx="0" cy="0"/>
           </a:xfrm>
           <a:prstGeom prst="line">
             <a:avLst/>
@@ -21256,8 +21464,8 @@
         </p:nvCxnSpPr>
         <p:spPr>
           <a:xfrm>
-            <a:off x="1371600" y="2414016.0"/>
-            <a:ext cx="0" cy="237744.0"/>
+            <a:off x="1371600" y="0"/>
+            <a:ext cx="0" cy="0"/>
           </a:xfrm>
           <a:prstGeom prst="line">
             <a:avLst/>
@@ -21328,8 +21536,8 @@
         </p:nvCxnSpPr>
         <p:spPr>
           <a:xfrm>
-            <a:off x="1371600" y="3054096.0"/>
-            <a:ext cx="0" cy="237744.0"/>
+            <a:off x="1371600" y="0"/>
+            <a:ext cx="0" cy="0"/>
           </a:xfrm>
           <a:prstGeom prst="line">
             <a:avLst/>
@@ -21400,8 +21608,8 @@
         </p:nvCxnSpPr>
         <p:spPr>
           <a:xfrm>
-            <a:off x="1371600" y="3694176.0"/>
-            <a:ext cx="0" cy="237743.0"/>
+            <a:off x="1371600" y="0"/>
+            <a:ext cx="0" cy="0"/>
           </a:xfrm>
           <a:prstGeom prst="line">
             <a:avLst/>
@@ -21472,8 +21680,8 @@
         </p:nvCxnSpPr>
         <p:spPr>
           <a:xfrm>
-            <a:off x="1371600" y="4334255.0"/>
-            <a:ext cx="0" cy="237745.0"/>
+            <a:off x="1371600" y="0"/>
+            <a:ext cx="0" cy="0"/>
           </a:xfrm>
           <a:prstGeom prst="line">
             <a:avLst/>
@@ -21544,8 +21752,8 @@
         </p:nvCxnSpPr>
         <p:spPr>
           <a:xfrm>
-            <a:off x="1929384.0" y="2852928"/>
-            <a:ext cx="347472.0" cy="0"/>
+            <a:off x="0" y="2852928"/>
+            <a:ext cx="0" cy="0"/>
           </a:xfrm>
           <a:prstGeom prst="line">
             <a:avLst/>
@@ -21616,8 +21824,8 @@
         </p:nvCxnSpPr>
         <p:spPr>
           <a:xfrm>
-            <a:off x="1929384.0" y="3493008"/>
-            <a:ext cx="347472.0" cy="0"/>
+            <a:off x="0" y="3493008"/>
+            <a:ext cx="0" cy="0"/>
           </a:xfrm>
           <a:prstGeom prst="line">
             <a:avLst/>
@@ -21688,8 +21896,8 @@
         </p:nvCxnSpPr>
         <p:spPr>
           <a:xfrm>
-            <a:off x="2834640" y="3694176.0"/>
-            <a:ext cx="0" cy="237743.0"/>
+            <a:off x="2834640" y="0"/>
+            <a:ext cx="0" cy="0"/>
           </a:xfrm>
           <a:prstGeom prst="line">
             <a:avLst/>
@@ -21795,6 +22003,7 @@
           <a:lstStyle/>
           <a:p>
             <a:pPr algn="ctr"/>
+            <a:endParaRPr/>
           </a:p>
         </p:txBody>
       </p:sp>
@@ -21876,6 +22085,7 @@
           <a:lstStyle/>
           <a:p>
             <a:pPr algn="ctr"/>
+            <a:endParaRPr/>
           </a:p>
         </p:txBody>
       </p:sp>
@@ -21920,6 +22130,7 @@
           <a:lstStyle/>
           <a:p>
             <a:pPr algn="ctr"/>
+            <a:endParaRPr/>
           </a:p>
         </p:txBody>
       </p:sp>
@@ -22036,6 +22247,7 @@
           <a:lstStyle/>
           <a:p>
             <a:pPr algn="ctr"/>
+            <a:endParaRPr/>
           </a:p>
         </p:txBody>
       </p:sp>
@@ -22115,6 +22327,7 @@
           <a:lstStyle/>
           <a:p>
             <a:pPr algn="ctr"/>
+            <a:endParaRPr/>
           </a:p>
         </p:txBody>
       </p:sp>
@@ -22197,8 +22410,8 @@
         </p:nvCxnSpPr>
         <p:spPr>
           <a:xfrm>
-            <a:off x="9299448.0" y="2505456"/>
-            <a:ext cx="0.0" cy="201168"/>
+            <a:off x="0" y="2505456"/>
+            <a:ext cx="0" cy="201168"/>
           </a:xfrm>
           <a:prstGeom prst="line">
             <a:avLst/>
@@ -22340,6 +22553,7 @@
           <a:lstStyle/>
           <a:p>
             <a:pPr algn="ctr"/>
+            <a:endParaRPr/>
           </a:p>
         </p:txBody>
       </p:sp>
@@ -22419,6 +22633,7 @@
           <a:lstStyle/>
           <a:p>
             <a:pPr algn="ctr"/>
+            <a:endParaRPr/>
           </a:p>
         </p:txBody>
       </p:sp>
@@ -22501,8 +22716,8 @@
         </p:nvCxnSpPr>
         <p:spPr>
           <a:xfrm>
-            <a:off x="9299448.0" y="3300984"/>
-            <a:ext cx="0.0" cy="201168"/>
+            <a:off x="0" y="3300984"/>
+            <a:ext cx="0" cy="201168"/>
           </a:xfrm>
           <a:prstGeom prst="line">
             <a:avLst/>
@@ -22644,6 +22859,7 @@
           <a:lstStyle/>
           <a:p>
             <a:pPr algn="ctr"/>
+            <a:endParaRPr/>
           </a:p>
         </p:txBody>
       </p:sp>
@@ -22723,6 +22939,7 @@
           <a:lstStyle/>
           <a:p>
             <a:pPr algn="ctr"/>
+            <a:endParaRPr/>
           </a:p>
         </p:txBody>
       </p:sp>
@@ -22805,8 +23022,8 @@
         </p:nvCxnSpPr>
         <p:spPr>
           <a:xfrm>
-            <a:off x="9299448.0" y="4096512"/>
-            <a:ext cx="0.0" cy="201168"/>
+            <a:off x="0" y="4096512"/>
+            <a:ext cx="0" cy="201168"/>
           </a:xfrm>
           <a:prstGeom prst="line">
             <a:avLst/>
@@ -22948,6 +23165,7 @@
           <a:lstStyle/>
           <a:p>
             <a:pPr algn="ctr"/>
+            <a:endParaRPr/>
           </a:p>
         </p:txBody>
       </p:sp>
@@ -23027,6 +23245,7 @@
           <a:lstStyle/>
           <a:p>
             <a:pPr algn="ctr"/>
+            <a:endParaRPr/>
           </a:p>
         </p:txBody>
       </p:sp>
@@ -23215,6 +23434,7 @@
           <a:lstStyle/>
           <a:p>
             <a:pPr algn="ctr"/>
+            <a:endParaRPr/>
           </a:p>
         </p:txBody>
       </p:sp>
@@ -23297,6 +23517,7 @@
           <a:lstStyle/>
           <a:p>
             <a:pPr algn="ctr"/>
+            <a:endParaRPr/>
           </a:p>
         </p:txBody>
       </p:sp>
@@ -23379,7 +23600,7 @@
 </file>
 
 <file path=ppt/slides/slide6.xml><?xml version="1.0" encoding="utf-8"?>
-<p:sld xmlns:a="http://schemas.openxmlformats.org/drawingml/2006/main" xmlns:p="http://schemas.openxmlformats.org/presentationml/2006/main" xmlns:r="http://schemas.openxmlformats.org/officeDocument/2006/relationships">
+<p:sld xmlns:a="http://schemas.openxmlformats.org/drawingml/2006/main" xmlns:r="http://schemas.openxmlformats.org/officeDocument/2006/relationships" xmlns:p="http://schemas.openxmlformats.org/presentationml/2006/main">
   <p:cSld>
     <p:bg>
       <p:bgPr>
@@ -23395,7 +23616,14 @@
         <p:cNvGrpSpPr/>
         <p:nvPr/>
       </p:nvGrpSpPr>
-      <p:grpSpPr/>
+      <p:grpSpPr>
+        <a:xfrm>
+          <a:off x="0" y="0"/>
+          <a:ext cx="0" cy="0"/>
+          <a:chOff x="0" y="0"/>
+          <a:chExt cx="0" cy="0"/>
+        </a:xfrm>
+      </p:grpSpPr>
       <p:sp>
         <p:nvSpPr>
           <p:cNvPr id="2" name="Rectangle 1"/>
@@ -23437,6 +23665,7 @@
           <a:lstStyle/>
           <a:p>
             <a:pPr algn="ctr"/>
+            <a:endParaRPr/>
           </a:p>
         </p:txBody>
       </p:sp>
@@ -23481,6 +23710,7 @@
           <a:lstStyle/>
           <a:p>
             <a:pPr algn="ctr"/>
+            <a:endParaRPr/>
           </a:p>
         </p:txBody>
       </p:sp>
@@ -23525,6 +23755,7 @@
           <a:lstStyle/>
           <a:p>
             <a:pPr algn="ctr"/>
+            <a:endParaRPr/>
           </a:p>
         </p:txBody>
       </p:sp>
@@ -23641,6 +23872,7 @@
           <a:lstStyle/>
           <a:p>
             <a:pPr algn="ctr"/>
+            <a:endParaRPr/>
           </a:p>
         </p:txBody>
       </p:sp>
@@ -23722,6 +23954,7 @@
           <a:lstStyle/>
           <a:p>
             <a:pPr algn="ctr"/>
+            <a:endParaRPr/>
           </a:p>
         </p:txBody>
       </p:sp>
@@ -23766,6 +23999,7 @@
           <a:lstStyle/>
           <a:p>
             <a:pPr algn="ctr"/>
+            <a:endParaRPr/>
           </a:p>
         </p:txBody>
       </p:sp>
@@ -23847,8 +24081,8 @@
         </p:nvCxnSpPr>
         <p:spPr>
           <a:xfrm>
-            <a:off x="2382012.0" y="1655064"/>
-            <a:ext cx="0.0" cy="228600"/>
+            <a:off x="0" y="1655064"/>
+            <a:ext cx="0" cy="228600"/>
           </a:xfrm>
           <a:prstGeom prst="line">
             <a:avLst/>
@@ -23954,6 +24188,7 @@
           <a:lstStyle/>
           <a:p>
             <a:pPr algn="ctr"/>
+            <a:endParaRPr/>
           </a:p>
         </p:txBody>
       </p:sp>
@@ -23998,6 +24233,7 @@
           <a:lstStyle/>
           <a:p>
             <a:pPr algn="ctr"/>
+            <a:endParaRPr/>
           </a:p>
         </p:txBody>
       </p:sp>
@@ -24079,6 +24315,7 @@
           <a:lstStyle/>
           <a:p>
             <a:pPr algn="ctr"/>
+            <a:endParaRPr/>
           </a:p>
         </p:txBody>
       </p:sp>
@@ -24195,6 +24432,7 @@
           <a:lstStyle/>
           <a:p>
             <a:pPr algn="ctr"/>
+            <a:endParaRPr/>
           </a:p>
         </p:txBody>
       </p:sp>
@@ -24311,6 +24549,7 @@
           <a:lstStyle/>
           <a:p>
             <a:pPr algn="ctr"/>
+            <a:endParaRPr/>
           </a:p>
         </p:txBody>
       </p:sp>
@@ -24427,6 +24666,7 @@
           <a:lstStyle/>
           <a:p>
             <a:pPr algn="ctr"/>
+            <a:endParaRPr/>
           </a:p>
         </p:txBody>
       </p:sp>
@@ -24508,8 +24748,8 @@
         </p:nvCxnSpPr>
         <p:spPr>
           <a:xfrm>
-            <a:off x="2382012.0" y="5148072"/>
-            <a:ext cx="0.0" cy="292608"/>
+            <a:off x="0" y="5148072"/>
+            <a:ext cx="0" cy="292608"/>
           </a:xfrm>
           <a:prstGeom prst="line">
             <a:avLst/>
@@ -24580,6 +24820,7 @@
           <a:lstStyle/>
           <a:p>
             <a:pPr algn="ctr"/>
+            <a:endParaRPr/>
           </a:p>
         </p:txBody>
       </p:sp>
@@ -24696,6 +24937,7 @@
           <a:lstStyle/>
           <a:p>
             <a:pPr algn="ctr"/>
+            <a:endParaRPr/>
           </a:p>
         </p:txBody>
       </p:sp>
@@ -24777,6 +25019,7 @@
           <a:lstStyle/>
           <a:p>
             <a:pPr algn="ctr"/>
+            <a:endParaRPr/>
           </a:p>
         </p:txBody>
       </p:sp>
@@ -24858,6 +25101,7 @@
           <a:lstStyle/>
           <a:p>
             <a:pPr algn="ctr"/>
+            <a:endParaRPr/>
           </a:p>
         </p:txBody>
       </p:sp>
@@ -24939,6 +25183,7 @@
           <a:lstStyle/>
           <a:p>
             <a:pPr algn="ctr"/>
+            <a:endParaRPr/>
           </a:p>
         </p:txBody>
       </p:sp>
@@ -24983,6 +25228,7 @@
           <a:lstStyle/>
           <a:p>
             <a:pPr algn="ctr"/>
+            <a:endParaRPr/>
           </a:p>
         </p:txBody>
       </p:sp>
@@ -25097,6 +25343,7 @@
           <a:lstStyle/>
           <a:p>
             <a:pPr algn="ctr"/>
+            <a:endParaRPr/>
           </a:p>
         </p:txBody>
       </p:sp>
@@ -25178,6 +25425,7 @@
           <a:lstStyle/>
           <a:p>
             <a:pPr algn="ctr"/>
+            <a:endParaRPr/>
           </a:p>
         </p:txBody>
       </p:sp>
@@ -25294,6 +25542,7 @@
           <a:lstStyle/>
           <a:p>
             <a:pPr algn="ctr"/>
+            <a:endParaRPr/>
           </a:p>
         </p:txBody>
       </p:sp>
@@ -25338,6 +25587,7 @@
           <a:lstStyle/>
           <a:p>
             <a:pPr algn="ctr"/>
+            <a:endParaRPr/>
           </a:p>
         </p:txBody>
       </p:sp>
@@ -25452,6 +25702,7 @@
           <a:lstStyle/>
           <a:p>
             <a:pPr algn="ctr"/>
+            <a:endParaRPr/>
           </a:p>
         </p:txBody>
       </p:sp>
@@ -25533,6 +25784,7 @@
           <a:lstStyle/>
           <a:p>
             <a:pPr algn="ctr"/>
+            <a:endParaRPr/>
           </a:p>
         </p:txBody>
       </p:sp>
@@ -25649,6 +25901,7 @@
           <a:lstStyle/>
           <a:p>
             <a:pPr algn="ctr"/>
+            <a:endParaRPr/>
           </a:p>
         </p:txBody>
       </p:sp>
@@ -25693,6 +25946,7 @@
           <a:lstStyle/>
           <a:p>
             <a:pPr algn="ctr"/>
+            <a:endParaRPr/>
           </a:p>
         </p:txBody>
       </p:sp>
@@ -25807,6 +26061,7 @@
           <a:lstStyle/>
           <a:p>
             <a:pPr algn="ctr"/>
+            <a:endParaRPr/>
           </a:p>
         </p:txBody>
       </p:sp>
@@ -25888,6 +26143,7 @@
           <a:lstStyle/>
           <a:p>
             <a:pPr algn="ctr"/>
+            <a:endParaRPr/>
           </a:p>
         </p:txBody>
       </p:sp>
@@ -26004,6 +26260,7 @@
           <a:lstStyle/>
           <a:p>
             <a:pPr algn="ctr"/>
+            <a:endParaRPr/>
           </a:p>
         </p:txBody>
       </p:sp>
@@ -26048,6 +26305,7 @@
           <a:lstStyle/>
           <a:p>
             <a:pPr algn="ctr"/>
+            <a:endParaRPr/>
           </a:p>
         </p:txBody>
       </p:sp>
@@ -26162,6 +26420,7 @@
           <a:lstStyle/>
           <a:p>
             <a:pPr algn="ctr"/>
+            <a:endParaRPr/>
           </a:p>
         </p:txBody>
       </p:sp>
@@ -26243,6 +26502,7 @@
           <a:lstStyle/>
           <a:p>
             <a:pPr algn="ctr"/>
+            <a:endParaRPr/>
           </a:p>
         </p:txBody>
       </p:sp>
@@ -26359,6 +26619,7 @@
           <a:lstStyle/>
           <a:p>
             <a:pPr algn="ctr"/>
+            <a:endParaRPr/>
           </a:p>
         </p:txBody>
       </p:sp>
@@ -26403,6 +26664,7 @@
           <a:lstStyle/>
           <a:p>
             <a:pPr algn="ctr"/>
+            <a:endParaRPr/>
           </a:p>
         </p:txBody>
       </p:sp>
@@ -26517,6 +26779,7 @@
           <a:lstStyle/>
           <a:p>
             <a:pPr algn="ctr"/>
+            <a:endParaRPr/>
           </a:p>
         </p:txBody>
       </p:sp>
@@ -26598,6 +26861,7 @@
           <a:lstStyle/>
           <a:p>
             <a:pPr algn="ctr"/>
+            <a:endParaRPr/>
           </a:p>
         </p:txBody>
       </p:sp>
@@ -26714,6 +26978,7 @@
           <a:lstStyle/>
           <a:p>
             <a:pPr algn="ctr"/>
+            <a:endParaRPr/>
           </a:p>
         </p:txBody>
       </p:sp>
@@ -26758,6 +27023,7 @@
           <a:lstStyle/>
           <a:p>
             <a:pPr algn="ctr"/>
+            <a:endParaRPr/>
           </a:p>
         </p:txBody>
       </p:sp>
@@ -26872,6 +27138,7 @@
           <a:lstStyle/>
           <a:p>
             <a:pPr algn="ctr"/>
+            <a:endParaRPr/>
           </a:p>
         </p:txBody>
       </p:sp>
@@ -26953,6 +27220,7 @@
           <a:lstStyle/>
           <a:p>
             <a:pPr algn="ctr"/>
+            <a:endParaRPr/>
           </a:p>
         </p:txBody>
       </p:sp>
@@ -27070,7 +27338,7 @@
 </file>
 
 <file path=ppt/slides/slide7.xml><?xml version="1.0" encoding="utf-8"?>
-<p:sld xmlns:a="http://schemas.openxmlformats.org/drawingml/2006/main" xmlns:p="http://schemas.openxmlformats.org/presentationml/2006/main" xmlns:r="http://schemas.openxmlformats.org/officeDocument/2006/relationships">
+<p:sld xmlns:a="http://schemas.openxmlformats.org/drawingml/2006/main" xmlns:r="http://schemas.openxmlformats.org/officeDocument/2006/relationships" xmlns:p="http://schemas.openxmlformats.org/presentationml/2006/main">
   <p:cSld>
     <p:bg>
       <p:bgPr>
@@ -27086,7 +27354,14 @@
         <p:cNvGrpSpPr/>
         <p:nvPr/>
       </p:nvGrpSpPr>
-      <p:grpSpPr/>
+      <p:grpSpPr>
+        <a:xfrm>
+          <a:off x="0" y="0"/>
+          <a:ext cx="0" cy="0"/>
+          <a:chOff x="0" y="0"/>
+          <a:chExt cx="0" cy="0"/>
+        </a:xfrm>
+      </p:grpSpPr>
       <p:sp>
         <p:nvSpPr>
           <p:cNvPr id="2" name="Rectangle 1"/>
@@ -27128,6 +27403,7 @@
           <a:lstStyle/>
           <a:p>
             <a:pPr algn="ctr"/>
+            <a:endParaRPr/>
           </a:p>
         </p:txBody>
       </p:sp>
@@ -27172,6 +27448,7 @@
           <a:lstStyle/>
           <a:p>
             <a:pPr algn="ctr"/>
+            <a:endParaRPr/>
           </a:p>
         </p:txBody>
       </p:sp>
@@ -27216,6 +27493,7 @@
           <a:lstStyle/>
           <a:p>
             <a:pPr algn="ctr"/>
+            <a:endParaRPr/>
           </a:p>
         </p:txBody>
       </p:sp>
@@ -27330,6 +27608,7 @@
           <a:lstStyle/>
           <a:p>
             <a:pPr algn="ctr"/>
+            <a:endParaRPr/>
           </a:p>
         </p:txBody>
       </p:sp>
@@ -27376,6 +27655,7 @@
           <a:lstStyle/>
           <a:p>
             <a:pPr algn="ctr"/>
+            <a:endParaRPr/>
           </a:p>
         </p:txBody>
       </p:sp>
@@ -27457,6 +27737,7 @@
           <a:lstStyle/>
           <a:p>
             <a:pPr algn="ctr"/>
+            <a:endParaRPr/>
           </a:p>
         </p:txBody>
       </p:sp>
@@ -27538,6 +27819,7 @@
           <a:lstStyle/>
           <a:p>
             <a:pPr algn="ctr"/>
+            <a:endParaRPr/>
           </a:p>
         </p:txBody>
       </p:sp>
@@ -27619,6 +27901,7 @@
           <a:lstStyle/>
           <a:p>
             <a:pPr algn="ctr"/>
+            <a:endParaRPr/>
           </a:p>
         </p:txBody>
       </p:sp>
@@ -27700,6 +27983,7 @@
           <a:lstStyle/>
           <a:p>
             <a:pPr algn="ctr"/>
+            <a:endParaRPr/>
           </a:p>
         </p:txBody>
       </p:sp>
@@ -27744,6 +28028,7 @@
           <a:lstStyle/>
           <a:p>
             <a:pPr algn="ctr"/>
+            <a:endParaRPr/>
           </a:p>
         </p:txBody>
       </p:sp>
@@ -27930,6 +28215,7 @@
           <a:lstStyle/>
           <a:p>
             <a:pPr algn="ctr"/>
+            <a:endParaRPr/>
           </a:p>
         </p:txBody>
       </p:sp>
@@ -27974,6 +28260,7 @@
           <a:lstStyle/>
           <a:p>
             <a:pPr algn="ctr"/>
+            <a:endParaRPr/>
           </a:p>
         </p:txBody>
       </p:sp>
@@ -28160,6 +28447,7 @@
           <a:lstStyle/>
           <a:p>
             <a:pPr algn="ctr"/>
+            <a:endParaRPr/>
           </a:p>
         </p:txBody>
       </p:sp>
@@ -28204,6 +28492,7 @@
           <a:lstStyle/>
           <a:p>
             <a:pPr algn="ctr"/>
+            <a:endParaRPr/>
           </a:p>
         </p:txBody>
       </p:sp>
@@ -28390,6 +28679,7 @@
           <a:lstStyle/>
           <a:p>
             <a:pPr algn="ctr"/>
+            <a:endParaRPr/>
           </a:p>
         </p:txBody>
       </p:sp>
@@ -28434,6 +28724,7 @@
           <a:lstStyle/>
           <a:p>
             <a:pPr algn="ctr"/>
+            <a:endParaRPr/>
           </a:p>
         </p:txBody>
       </p:sp>
@@ -28620,6 +28911,7 @@
           <a:lstStyle/>
           <a:p>
             <a:pPr algn="ctr"/>
+            <a:endParaRPr/>
           </a:p>
         </p:txBody>
       </p:sp>
@@ -28664,6 +28956,7 @@
           <a:lstStyle/>
           <a:p>
             <a:pPr algn="ctr"/>
+            <a:endParaRPr/>
           </a:p>
         </p:txBody>
       </p:sp>
@@ -28850,6 +29143,7 @@
           <a:lstStyle/>
           <a:p>
             <a:pPr algn="ctr"/>
+            <a:endParaRPr/>
           </a:p>
         </p:txBody>
       </p:sp>
@@ -28894,6 +29188,7 @@
           <a:lstStyle/>
           <a:p>
             <a:pPr algn="ctr"/>
+            <a:endParaRPr/>
           </a:p>
         </p:txBody>
       </p:sp>
@@ -29080,6 +29375,7 @@
           <a:lstStyle/>
           <a:p>
             <a:pPr algn="ctr"/>
+            <a:endParaRPr/>
           </a:p>
         </p:txBody>
       </p:sp>
@@ -29124,6 +29420,7 @@
           <a:lstStyle/>
           <a:p>
             <a:pPr algn="ctr"/>
+            <a:endParaRPr/>
           </a:p>
         </p:txBody>
       </p:sp>
@@ -29310,6 +29607,7 @@
           <a:lstStyle/>
           <a:p>
             <a:pPr algn="ctr"/>
+            <a:endParaRPr/>
           </a:p>
         </p:txBody>
       </p:sp>
@@ -29354,6 +29652,7 @@
           <a:lstStyle/>
           <a:p>
             <a:pPr algn="ctr"/>
+            <a:endParaRPr/>
           </a:p>
         </p:txBody>
       </p:sp>
@@ -29540,6 +29839,7 @@
           <a:lstStyle/>
           <a:p>
             <a:pPr algn="ctr"/>
+            <a:endParaRPr/>
           </a:p>
         </p:txBody>
       </p:sp>
@@ -29584,6 +29884,7 @@
           <a:lstStyle/>
           <a:p>
             <a:pPr algn="ctr"/>
+            <a:endParaRPr/>
           </a:p>
         </p:txBody>
       </p:sp>
@@ -29770,6 +30071,7 @@
           <a:lstStyle/>
           <a:p>
             <a:pPr algn="ctr"/>
+            <a:endParaRPr/>
           </a:p>
         </p:txBody>
       </p:sp>
@@ -29814,6 +30116,7 @@
           <a:lstStyle/>
           <a:p>
             <a:pPr algn="ctr"/>
+            <a:endParaRPr/>
           </a:p>
         </p:txBody>
       </p:sp>
@@ -30000,6 +30303,7 @@
           <a:lstStyle/>
           <a:p>
             <a:pPr algn="ctr"/>
+            <a:endParaRPr/>
           </a:p>
         </p:txBody>
       </p:sp>
@@ -30044,6 +30348,7 @@
           <a:lstStyle/>
           <a:p>
             <a:pPr algn="ctr"/>
+            <a:endParaRPr/>
           </a:p>
         </p:txBody>
       </p:sp>
@@ -30230,6 +30535,7 @@
           <a:lstStyle/>
           <a:p>
             <a:pPr algn="ctr"/>
+            <a:endParaRPr/>
           </a:p>
         </p:txBody>
       </p:sp>
@@ -30312,7 +30618,7 @@
 </file>
 
 <file path=ppt/slides/slide8.xml><?xml version="1.0" encoding="utf-8"?>
-<p:sld xmlns:a="http://schemas.openxmlformats.org/drawingml/2006/main" xmlns:p="http://schemas.openxmlformats.org/presentationml/2006/main" xmlns:r="http://schemas.openxmlformats.org/officeDocument/2006/relationships">
+<p:sld xmlns:a="http://schemas.openxmlformats.org/drawingml/2006/main" xmlns:r="http://schemas.openxmlformats.org/officeDocument/2006/relationships" xmlns:p="http://schemas.openxmlformats.org/presentationml/2006/main">
   <p:cSld>
     <p:bg>
       <p:bgPr>
@@ -30328,7 +30634,14 @@
         <p:cNvGrpSpPr/>
         <p:nvPr/>
       </p:nvGrpSpPr>
-      <p:grpSpPr/>
+      <p:grpSpPr>
+        <a:xfrm>
+          <a:off x="0" y="0"/>
+          <a:ext cx="0" cy="0"/>
+          <a:chOff x="0" y="0"/>
+          <a:chExt cx="0" cy="0"/>
+        </a:xfrm>
+      </p:grpSpPr>
       <p:sp>
         <p:nvSpPr>
           <p:cNvPr id="2" name="Rectangle 1"/>
@@ -30370,6 +30683,7 @@
           <a:lstStyle/>
           <a:p>
             <a:pPr algn="ctr"/>
+            <a:endParaRPr/>
           </a:p>
         </p:txBody>
       </p:sp>
@@ -30414,6 +30728,7 @@
           <a:lstStyle/>
           <a:p>
             <a:pPr algn="ctr"/>
+            <a:endParaRPr/>
           </a:p>
         </p:txBody>
       </p:sp>
@@ -30458,6 +30773,7 @@
           <a:lstStyle/>
           <a:p>
             <a:pPr algn="ctr"/>
+            <a:endParaRPr/>
           </a:p>
         </p:txBody>
       </p:sp>
@@ -30574,6 +30890,7 @@
           <a:lstStyle/>
           <a:p>
             <a:pPr algn="ctr"/>
+            <a:endParaRPr/>
           </a:p>
         </p:txBody>
       </p:sp>
@@ -30655,6 +30972,7 @@
           <a:lstStyle/>
           <a:p>
             <a:pPr algn="ctr"/>
+            <a:endParaRPr/>
           </a:p>
         </p:txBody>
       </p:sp>
@@ -30701,6 +31019,7 @@
           <a:lstStyle/>
           <a:p>
             <a:pPr algn="ctr"/>
+            <a:endParaRPr/>
           </a:p>
         </p:txBody>
       </p:sp>
@@ -30818,6 +31137,7 @@
           <a:lstStyle/>
           <a:p>
             <a:pPr algn="ctr"/>
+            <a:endParaRPr/>
           </a:p>
         </p:txBody>
       </p:sp>
@@ -30899,6 +31219,7 @@
           <a:lstStyle/>
           <a:p>
             <a:pPr algn="ctr"/>
+            <a:endParaRPr/>
           </a:p>
         </p:txBody>
       </p:sp>
@@ -30943,6 +31264,7 @@
           <a:lstStyle/>
           <a:p>
             <a:pPr algn="ctr"/>
+            <a:endParaRPr/>
           </a:p>
         </p:txBody>
       </p:sp>
@@ -31060,6 +31382,7 @@
           <a:lstStyle/>
           <a:p>
             <a:pPr algn="ctr"/>
+            <a:endParaRPr/>
           </a:p>
         </p:txBody>
       </p:sp>
@@ -31104,6 +31427,7 @@
           <a:lstStyle/>
           <a:p>
             <a:pPr algn="ctr"/>
+            <a:endParaRPr/>
           </a:p>
         </p:txBody>
       </p:sp>
@@ -31221,6 +31545,7 @@
           <a:lstStyle/>
           <a:p>
             <a:pPr algn="ctr"/>
+            <a:endParaRPr/>
           </a:p>
         </p:txBody>
       </p:sp>
@@ -31265,6 +31590,7 @@
           <a:lstStyle/>
           <a:p>
             <a:pPr algn="ctr"/>
+            <a:endParaRPr/>
           </a:p>
         </p:txBody>
       </p:sp>
@@ -31382,6 +31708,7 @@
           <a:lstStyle/>
           <a:p>
             <a:pPr algn="ctr"/>
+            <a:endParaRPr/>
           </a:p>
         </p:txBody>
       </p:sp>
@@ -31500,6 +31827,7 @@
           <a:lstStyle/>
           <a:p>
             <a:pPr algn="ctr"/>
+            <a:endParaRPr/>
           </a:p>
         </p:txBody>
       </p:sp>
@@ -31546,6 +31874,7 @@
           <a:lstStyle/>
           <a:p>
             <a:pPr algn="ctr"/>
+            <a:endParaRPr/>
           </a:p>
         </p:txBody>
       </p:sp>
@@ -31663,6 +31992,7 @@
           <a:lstStyle/>
           <a:p>
             <a:pPr algn="ctr"/>
+            <a:endParaRPr/>
           </a:p>
         </p:txBody>
       </p:sp>
@@ -31744,6 +32074,7 @@
           <a:lstStyle/>
           <a:p>
             <a:pPr algn="ctr"/>
+            <a:endParaRPr/>
           </a:p>
         </p:txBody>
       </p:sp>
@@ -31788,6 +32119,7 @@
           <a:lstStyle/>
           <a:p>
             <a:pPr algn="ctr"/>
+            <a:endParaRPr/>
           </a:p>
         </p:txBody>
       </p:sp>
@@ -31905,6 +32237,7 @@
           <a:lstStyle/>
           <a:p>
             <a:pPr algn="ctr"/>
+            <a:endParaRPr/>
           </a:p>
         </p:txBody>
       </p:sp>
@@ -31949,6 +32282,7 @@
           <a:lstStyle/>
           <a:p>
             <a:pPr algn="ctr"/>
+            <a:endParaRPr/>
           </a:p>
         </p:txBody>
       </p:sp>
@@ -32066,6 +32400,7 @@
           <a:lstStyle/>
           <a:p>
             <a:pPr algn="ctr"/>
+            <a:endParaRPr/>
           </a:p>
         </p:txBody>
       </p:sp>
@@ -32110,6 +32445,7 @@
           <a:lstStyle/>
           <a:p>
             <a:pPr algn="ctr"/>
+            <a:endParaRPr/>
           </a:p>
         </p:txBody>
       </p:sp>
@@ -32227,6 +32563,7 @@
           <a:lstStyle/>
           <a:p>
             <a:pPr algn="ctr"/>
+            <a:endParaRPr/>
           </a:p>
         </p:txBody>
       </p:sp>
@@ -32271,6 +32608,7 @@
           <a:lstStyle/>
           <a:p>
             <a:pPr algn="ctr"/>
+            <a:endParaRPr/>
           </a:p>
         </p:txBody>
       </p:sp>
@@ -32388,6 +32726,7 @@
           <a:lstStyle/>
           <a:p>
             <a:pPr algn="ctr"/>
+            <a:endParaRPr/>
           </a:p>
         </p:txBody>
       </p:sp>
@@ -32507,6 +32846,7 @@
           <a:lstStyle/>
           <a:p>
             <a:pPr algn="ctr"/>
+            <a:endParaRPr/>
           </a:p>
         </p:txBody>
       </p:sp>
@@ -32553,6 +32893,7 @@
           <a:lstStyle/>
           <a:p>
             <a:pPr algn="ctr"/>
+            <a:endParaRPr/>
           </a:p>
         </p:txBody>
       </p:sp>
@@ -32670,6 +33011,7 @@
           <a:lstStyle/>
           <a:p>
             <a:pPr algn="ctr"/>
+            <a:endParaRPr/>
           </a:p>
         </p:txBody>
       </p:sp>
@@ -32751,6 +33093,7 @@
           <a:lstStyle/>
           <a:p>
             <a:pPr algn="ctr"/>
+            <a:endParaRPr/>
           </a:p>
         </p:txBody>
       </p:sp>
@@ -32795,6 +33138,7 @@
           <a:lstStyle/>
           <a:p>
             <a:pPr algn="ctr"/>
+            <a:endParaRPr/>
           </a:p>
         </p:txBody>
       </p:sp>
@@ -32914,6 +33258,7 @@
           <a:lstStyle/>
           <a:p>
             <a:pPr algn="ctr"/>
+            <a:endParaRPr/>
           </a:p>
         </p:txBody>
       </p:sp>
@@ -32958,6 +33303,7 @@
           <a:lstStyle/>
           <a:p>
             <a:pPr algn="ctr"/>
+            <a:endParaRPr/>
           </a:p>
         </p:txBody>
       </p:sp>
@@ -33076,6 +33422,7 @@
           <a:lstStyle/>
           <a:p>
             <a:pPr algn="ctr"/>
+            <a:endParaRPr/>
           </a:p>
         </p:txBody>
       </p:sp>
@@ -33120,6 +33467,7 @@
           <a:lstStyle/>
           <a:p>
             <a:pPr algn="ctr"/>
+            <a:endParaRPr/>
           </a:p>
         </p:txBody>
       </p:sp>
@@ -33238,6 +33586,7 @@
           <a:lstStyle/>
           <a:p>
             <a:pPr algn="ctr"/>
+            <a:endParaRPr/>
           </a:p>
         </p:txBody>
       </p:sp>
@@ -33357,6 +33706,7 @@
           <a:lstStyle/>
           <a:p>
             <a:pPr algn="ctr"/>
+            <a:endParaRPr/>
           </a:p>
         </p:txBody>
       </p:sp>
@@ -33403,6 +33753,7 @@
           <a:lstStyle/>
           <a:p>
             <a:pPr algn="ctr"/>
+            <a:endParaRPr/>
           </a:p>
         </p:txBody>
       </p:sp>
@@ -33520,6 +33871,7 @@
           <a:lstStyle/>
           <a:p>
             <a:pPr algn="ctr"/>
+            <a:endParaRPr/>
           </a:p>
         </p:txBody>
       </p:sp>
@@ -33601,6 +33953,7 @@
           <a:lstStyle/>
           <a:p>
             <a:pPr algn="ctr"/>
+            <a:endParaRPr/>
           </a:p>
         </p:txBody>
       </p:sp>
@@ -33645,6 +33998,7 @@
           <a:lstStyle/>
           <a:p>
             <a:pPr algn="ctr"/>
+            <a:endParaRPr/>
           </a:p>
         </p:txBody>
       </p:sp>
@@ -33764,6 +34118,7 @@
           <a:lstStyle/>
           <a:p>
             <a:pPr algn="ctr"/>
+            <a:endParaRPr/>
           </a:p>
         </p:txBody>
       </p:sp>
@@ -33845,6 +34200,7 @@
           <a:lstStyle/>
           <a:p>
             <a:pPr algn="ctr"/>
+            <a:endParaRPr/>
           </a:p>
         </p:txBody>
       </p:sp>
@@ -34382,7 +34738,7 @@
 </file>
 
 <file path=ppt/slides/slide9.xml><?xml version="1.0" encoding="utf-8"?>
-<p:sld xmlns:a="http://schemas.openxmlformats.org/drawingml/2006/main" xmlns:p="http://schemas.openxmlformats.org/presentationml/2006/main" xmlns:r="http://schemas.openxmlformats.org/officeDocument/2006/relationships">
+<p:sld xmlns:a="http://schemas.openxmlformats.org/drawingml/2006/main" xmlns:r="http://schemas.openxmlformats.org/officeDocument/2006/relationships" xmlns:p="http://schemas.openxmlformats.org/presentationml/2006/main">
   <p:cSld>
     <p:bg>
       <p:bgPr>
@@ -34398,7 +34754,14 @@
         <p:cNvGrpSpPr/>
         <p:nvPr/>
       </p:nvGrpSpPr>
-      <p:grpSpPr/>
+      <p:grpSpPr>
+        <a:xfrm>
+          <a:off x="0" y="0"/>
+          <a:ext cx="0" cy="0"/>
+          <a:chOff x="0" y="0"/>
+          <a:chExt cx="0" cy="0"/>
+        </a:xfrm>
+      </p:grpSpPr>
       <p:sp>
         <p:nvSpPr>
           <p:cNvPr id="2" name="Rectangle 1"/>
@@ -34440,6 +34803,7 @@
           <a:lstStyle/>
           <a:p>
             <a:pPr algn="ctr"/>
+            <a:endParaRPr/>
           </a:p>
         </p:txBody>
       </p:sp>
@@ -34484,6 +34848,7 @@
           <a:lstStyle/>
           <a:p>
             <a:pPr algn="ctr"/>
+            <a:endParaRPr/>
           </a:p>
         </p:txBody>
       </p:sp>
@@ -34528,6 +34893,7 @@
           <a:lstStyle/>
           <a:p>
             <a:pPr algn="ctr"/>
+            <a:endParaRPr/>
           </a:p>
         </p:txBody>
       </p:sp>
@@ -34644,6 +35010,7 @@
           <a:lstStyle/>
           <a:p>
             <a:pPr algn="ctr"/>
+            <a:endParaRPr/>
           </a:p>
         </p:txBody>
       </p:sp>
@@ -34688,6 +35055,7 @@
           <a:lstStyle/>
           <a:p>
             <a:pPr algn="ctr"/>
+            <a:endParaRPr/>
           </a:p>
         </p:txBody>
       </p:sp>
@@ -34771,8 +35139,8 @@
         </p:nvCxnSpPr>
         <p:spPr>
           <a:xfrm>
-            <a:off x="2560320" y="1696212.0"/>
-            <a:ext cx="237744" cy="0.0"/>
+            <a:off x="2560320" y="0"/>
+            <a:ext cx="237744" cy="0"/>
           </a:xfrm>
           <a:prstGeom prst="line">
             <a:avLst/>
@@ -34843,6 +35211,7 @@
           <a:lstStyle/>
           <a:p>
             <a:pPr algn="ctr"/>
+            <a:endParaRPr/>
           </a:p>
         </p:txBody>
       </p:sp>
@@ -34887,6 +35256,7 @@
           <a:lstStyle/>
           <a:p>
             <a:pPr algn="ctr"/>
+            <a:endParaRPr/>
           </a:p>
         </p:txBody>
       </p:sp>
@@ -35006,6 +35376,7 @@
           <a:lstStyle/>
           <a:p>
             <a:pPr algn="ctr"/>
+            <a:endParaRPr/>
           </a:p>
         </p:txBody>
       </p:sp>
@@ -35017,8 +35388,8 @@
         </p:nvCxnSpPr>
         <p:spPr>
           <a:xfrm flipH="1">
-            <a:off x="5038344" y="1696212.0"/>
-            <a:ext cx="91440" cy="0.0"/>
+            <a:off x="5038344" y="0"/>
+            <a:ext cx="91440" cy="0"/>
           </a:xfrm>
           <a:prstGeom prst="line">
             <a:avLst/>
@@ -35089,6 +35460,7 @@
           <a:lstStyle/>
           <a:p>
             <a:pPr algn="ctr"/>
+            <a:endParaRPr/>
           </a:p>
         </p:txBody>
       </p:sp>
@@ -35133,6 +35505,7 @@
           <a:lstStyle/>
           <a:p>
             <a:pPr algn="ctr"/>
+            <a:endParaRPr/>
           </a:p>
         </p:txBody>
       </p:sp>
@@ -35216,8 +35589,8 @@
         </p:nvCxnSpPr>
         <p:spPr>
           <a:xfrm>
-            <a:off x="5367528" y="1604772.0"/>
-            <a:ext cx="73152" cy="0.0"/>
+            <a:off x="5367528" y="0"/>
+            <a:ext cx="73152" cy="0"/>
           </a:xfrm>
           <a:prstGeom prst="line">
             <a:avLst/>
@@ -35323,6 +35696,7 @@
           <a:lstStyle/>
           <a:p>
             <a:pPr algn="ctr"/>
+            <a:endParaRPr/>
           </a:p>
         </p:txBody>
       </p:sp>
@@ -35367,6 +35741,7 @@
           <a:lstStyle/>
           <a:p>
             <a:pPr algn="ctr"/>
+            <a:endParaRPr/>
           </a:p>
         </p:txBody>
       </p:sp>
@@ -35450,8 +35825,8 @@
         </p:nvCxnSpPr>
         <p:spPr>
           <a:xfrm>
-            <a:off x="5367528" y="1787652.0"/>
-            <a:ext cx="73152" cy="1856232.0"/>
+            <a:off x="5367528" y="0"/>
+            <a:ext cx="73152" cy="0"/>
           </a:xfrm>
           <a:prstGeom prst="line">
             <a:avLst/>
@@ -35557,6 +35932,7 @@
           <a:lstStyle/>
           <a:p>
             <a:pPr algn="ctr"/>
+            <a:endParaRPr/>
           </a:p>
         </p:txBody>
       </p:sp>
@@ -35601,6 +35977,7 @@
           <a:lstStyle/>
           <a:p>
             <a:pPr algn="ctr"/>
+            <a:endParaRPr/>
           </a:p>
         </p:txBody>
       </p:sp>
@@ -35682,6 +36059,7 @@
           <a:lstStyle/>
           <a:p>
             <a:pPr algn="ctr"/>
+            <a:endParaRPr/>
           </a:p>
         </p:txBody>
       </p:sp>
@@ -35726,6 +36104,7 @@
           <a:lstStyle/>
           <a:p>
             <a:pPr algn="ctr"/>
+            <a:endParaRPr/>
           </a:p>
         </p:txBody>
       </p:sp>
@@ -35843,6 +36222,7 @@
           <a:lstStyle/>
           <a:p>
             <a:pPr algn="ctr"/>
+            <a:endParaRPr/>
           </a:p>
         </p:txBody>
       </p:sp>
@@ -35887,6 +36267,7 @@
           <a:lstStyle/>
           <a:p>
             <a:pPr algn="ctr"/>
+            <a:endParaRPr/>
           </a:p>
         </p:txBody>
       </p:sp>
@@ -35970,8 +36351,8 @@
         </p:nvCxnSpPr>
         <p:spPr>
           <a:xfrm>
-            <a:off x="1730502.0" y="5852160.0"/>
-            <a:ext cx="73152.0" cy="0.0"/>
+            <a:off x="0" y="0"/>
+            <a:ext cx="0" cy="0"/>
           </a:xfrm>
           <a:prstGeom prst="line">
             <a:avLst/>
@@ -36042,6 +36423,7 @@
           <a:lstStyle/>
           <a:p>
             <a:pPr algn="ctr"/>
+            <a:endParaRPr/>
           </a:p>
         </p:txBody>
       </p:sp>
@@ -36086,6 +36468,7 @@
           <a:lstStyle/>
           <a:p>
             <a:pPr algn="ctr"/>
+            <a:endParaRPr/>
           </a:p>
         </p:txBody>
       </p:sp>
@@ -36169,8 +36552,8 @@
         </p:nvCxnSpPr>
         <p:spPr>
           <a:xfrm>
-            <a:off x="3232404.0" y="5852160.0"/>
-            <a:ext cx="73152.0" cy="0.0"/>
+            <a:off x="0" y="0"/>
+            <a:ext cx="0" cy="0"/>
           </a:xfrm>
           <a:prstGeom prst="line">
             <a:avLst/>
@@ -36241,6 +36624,7 @@
           <a:lstStyle/>
           <a:p>
             <a:pPr algn="ctr"/>
+            <a:endParaRPr/>
           </a:p>
         </p:txBody>
       </p:sp>
@@ -36285,6 +36669,7 @@
           <a:lstStyle/>
           <a:p>
             <a:pPr algn="ctr"/>
+            <a:endParaRPr/>
           </a:p>
         </p:txBody>
       </p:sp>
@@ -36368,8 +36753,8 @@
         </p:nvCxnSpPr>
         <p:spPr>
           <a:xfrm>
-            <a:off x="4734306.0" y="5852160.0"/>
-            <a:ext cx="73152.0" cy="0.0"/>
+            <a:off x="0" y="0"/>
+            <a:ext cx="0" cy="0"/>
           </a:xfrm>
           <a:prstGeom prst="line">
             <a:avLst/>
@@ -36440,6 +36825,7 @@
           <a:lstStyle/>
           <a:p>
             <a:pPr algn="ctr"/>
+            <a:endParaRPr/>
           </a:p>
         </p:txBody>
       </p:sp>
@@ -36484,6 +36870,7 @@
           <a:lstStyle/>
           <a:p>
             <a:pPr algn="ctr"/>
+            <a:endParaRPr/>
           </a:p>
         </p:txBody>
       </p:sp>
@@ -36530,8 +36917,8 @@
         </p:nvCxnSpPr>
         <p:spPr>
           <a:xfrm>
-            <a:off x="6236208.0" y="5852160.0"/>
-            <a:ext cx="73152.0" cy="0.0"/>
+            <a:off x="0" y="0"/>
+            <a:ext cx="0" cy="0"/>
           </a:xfrm>
           <a:prstGeom prst="line">
             <a:avLst/>
@@ -36605,8 +36992,8 @@
         </p:nvCxnSpPr>
         <p:spPr>
           <a:xfrm flipH="1">
-            <a:off x="1016127.0" y="6537960"/>
-            <a:ext cx="4505706.0" cy="0"/>
+            <a:off x="0" y="6537960"/>
+            <a:ext cx="0" cy="0"/>
           </a:xfrm>
           <a:prstGeom prst="line">
             <a:avLst/>
@@ -36712,6 +37099,7 @@
           <a:lstStyle/>
           <a:p>
             <a:pPr algn="ctr"/>
+            <a:endParaRPr/>
           </a:p>
         </p:txBody>
       </p:sp>
@@ -36756,6 +37144,7 @@
           <a:lstStyle/>
           <a:p>
             <a:pPr algn="ctr"/>
+            <a:endParaRPr/>
           </a:p>
         </p:txBody>
       </p:sp>
@@ -36906,6 +37295,7 @@
           <a:lstStyle/>
           <a:p>
             <a:pPr algn="ctr"/>
+            <a:endParaRPr/>
           </a:p>
         </p:txBody>
       </p:sp>
@@ -36987,6 +37377,7 @@
           <a:lstStyle/>
           <a:p>
             <a:pPr algn="ctr"/>
+            <a:endParaRPr/>
           </a:p>
         </p:txBody>
       </p:sp>
@@ -37138,6 +37529,7 @@
           <a:lstStyle/>
           <a:p>
             <a:pPr algn="ctr"/>
+            <a:endParaRPr/>
           </a:p>
         </p:txBody>
       </p:sp>
@@ -37289,6 +37681,7 @@
           <a:lstStyle/>
           <a:p>
             <a:pPr algn="ctr"/>
+            <a:endParaRPr/>
           </a:p>
         </p:txBody>
       </p:sp>
@@ -37440,6 +37833,7 @@
           <a:lstStyle/>
           <a:p>
             <a:pPr algn="ctr"/>
+            <a:endParaRPr/>
           </a:p>
         </p:txBody>
       </p:sp>

</xml_diff>